<commit_message>
Cierre de la entrega: enlace a entrega-final, presentación con QR nuevo y ajustes del informe
- Resumen y limitación 4: días sin PM2.5 en NO, NE2 y SUR y en 2024–2025.
- Radiación como efecto débil (5.5, Tabla 9 y pie de la Figura 5).
- Enlace del informe a la etiqueta entrega-final; informe-final queda como
  la versión previa a la retroalimentación del 22 de octubre.
- Presentación: diapositiva 12 con la etiqueta entrega-final y QR nuevo;
  frase de MIMA-v1 corregida (dataset, no código); trazabilidad sin el
  nombre del personal de SIMA; .pptx y PDF exportados de nuevo.

Co-Authored-By: Claude Opus 5.5 <noreply@anthropic.com>
</commit_message>
<xml_diff>
--- a/docs/presentacion_final/Presentacion_final_SIMA_Equipo1.pptx
+++ b/docs/presentacion_final/Presentacion_final_SIMA_Equipo1.pptx
@@ -4,6 +4,9 @@
   <p:sldMasterIdLst>
     <p:sldMasterId id="2147483648" r:id="rId1"/>
   </p:sldMasterIdLst>
+  <p:notesMasterIdLst>
+    <p:notesMasterId r:id="rId14"/>
+  </p:notesMasterIdLst>
   <p:sldIdLst>
     <p:sldId id="256" r:id="rId2"/>
     <p:sldId id="257" r:id="rId3"/>
@@ -18,9 +21,6 @@
     <p:sldId id="266" r:id="rId12"/>
     <p:sldId id="267" r:id="rId13"/>
   </p:sldIdLst>
-  <p:notesMasterIdLst>
-    <p:notesMasterId r:id="rId14"/>
-  </p:notesMasterIdLst>
   <p:sldSz cx="12192000" cy="6858000"/>
   <p:notesSz cx="6858000" cy="12192000"/>
   <p:defaultTextStyle>
@@ -118,12 +118,12 @@
   <p:extLst>
     <p:ext uri="{521415D9-36F7-43E2-AB2F-B90AF26B5E84}">
       <p14:sectionLst xmlns:p14="http://schemas.microsoft.com/office/powerpoint/2010/main">
-        <p14:section name="Inicio" id="{85c17bae-88c8-d7f4-ce2a-001c11a13811}">
+        <p14:section name="Inicio" id="{85C17BAE-88C8-D7F4-CE2A-001C11A13811}">
           <p14:sldIdLst>
             <p14:sldId id="256"/>
           </p14:sldIdLst>
         </p14:section>
-        <p14:section name="Problema y datos" id="{7eed65c2-3fec-3c61-8b9d-8cad03fde6a5}">
+        <p14:section name="Problema y datos" id="{7EED65C2-3FEC-3C61-8B9D-8CAD03FDE6A5}">
           <p14:sldIdLst>
             <p14:sldId id="257"/>
             <p14:sldId id="258"/>
@@ -131,20 +131,20 @@
             <p14:sldId id="260"/>
           </p14:sldIdLst>
         </p14:section>
-        <p14:section name="Método" id="{fba8ff12-ed9c-8220-2b35-04058edae1ed}">
+        <p14:section name="Método" id="{FBA8FF12-ED9C-8220-2B35-04058EDAE1ED}">
           <p14:sldIdLst>
             <p14:sldId id="261"/>
             <p14:sldId id="262"/>
           </p14:sldIdLst>
         </p14:section>
-        <p14:section name="Resultados" id="{276f8733-2b19-3200-4fc5-ab7ac87edb15}">
+        <p14:section name="Resultados" id="{276F8733-2B19-3200-4FC5-AB7AC87EDB15}">
           <p14:sldIdLst>
             <p14:sldId id="263"/>
             <p14:sldId id="264"/>
             <p14:sldId id="265"/>
           </p14:sldIdLst>
         </p14:section>
-        <p14:section name="Cierre" id="{d53e690f-21bb-d24d-d696-0d6aa8b35f41}">
+        <p14:section name="Cierre" id="{D53E690F-21BB-D24D-D696-0D6AA8B35F41}">
           <p14:sldIdLst>
             <p14:sldId id="266"/>
             <p14:sldId id="267"/>
@@ -181,234 +181,10 @@
           <a:chExt cx="0" cy="0"/>
         </a:xfrm>
       </p:grpSpPr>
-      <p:sp>
-        <p:nvSpPr>
-          <p:cNvPr id="2" name="Header Placeholder 1"/>
-          <p:cNvSpPr>
-            <a:spLocks noGrp="1"/>
-          </p:cNvSpPr>
-          <p:nvPr>
-            <p:ph type="hdr" sz="quarter"/>
-          </p:nvPr>
-        </p:nvSpPr>
-        <p:spPr>
-          <a:xfrm>
-            <a:off x="0" y="0"/>
-            <a:ext cx="2971800" cy="458788"/>
-          </a:xfrm>
-          <a:prstGeom prst="rect">
-            <a:avLst/>
-          </a:prstGeom>
-        </p:spPr>
-        <p:txBody>
-          <a:bodyPr vert="horz" lIns="91440" tIns="45720" rIns="91440" bIns="45720" rtlCol="0"/>
-          <a:lstStyle>
-            <a:lvl1pPr algn="l">
-              <a:defRPr sz="1200"/>
-            </a:lvl1pPr>
-          </a:lstStyle>
-          <a:p>
-            <a:endParaRPr lang="en-US"/>
-          </a:p>
-        </p:txBody>
-      </p:sp>
-      <p:sp>
-        <p:nvSpPr>
-          <p:cNvPr id="3" name="Date Placeholder 2"/>
-          <p:cNvSpPr>
-            <a:spLocks noGrp="1"/>
-          </p:cNvSpPr>
-          <p:nvPr>
-            <p:ph type="dt" idx="1"/>
-          </p:nvPr>
-        </p:nvSpPr>
-        <p:spPr>
-          <a:xfrm>
-            <a:off x="3884613" y="0"/>
-            <a:ext cx="2971800" cy="458788"/>
-          </a:xfrm>
-          <a:prstGeom prst="rect">
-            <a:avLst/>
-          </a:prstGeom>
-        </p:spPr>
-        <p:txBody>
-          <a:bodyPr vert="horz" lIns="91440" tIns="45720" rIns="91440" bIns="45720" rtlCol="0"/>
-          <a:lstStyle>
-            <a:lvl1pPr algn="r">
-              <a:defRPr sz="1200"/>
-            </a:lvl1pPr>
-          </a:lstStyle>
-          <a:p>
-            <a:fld id="{5282F153-3F37-0F45-9E97-73ACFA13230C}" type="datetimeFigureOut">
-              <a:rPr lang="en-US"/>
-              <a:t>7/23/19</a:t>
-            </a:fld>
-            <a:endParaRPr lang="en-US"/>
-          </a:p>
-        </p:txBody>
-      </p:sp>
-      <p:sp>
-        <p:nvSpPr>
-          <p:cNvPr id="4" name="Slide Image Placeholder 3"/>
-          <p:cNvSpPr>
-            <a:spLocks noGrp="1" noRot="1" noChangeAspect="1"/>
-          </p:cNvSpPr>
-          <p:nvPr>
-            <p:ph type="sldImg" idx="2"/>
-          </p:nvPr>
-        </p:nvSpPr>
-        <p:spPr>
-          <a:xfrm>
-            <a:off x="685800" y="1143000"/>
-            <a:ext cx="5486400" cy="3086100"/>
-          </a:xfrm>
-          <a:prstGeom prst="rect">
-            <a:avLst/>
-          </a:prstGeom>
-          <a:noFill/>
-          <a:ln w="12700">
-            <a:solidFill>
-              <a:prstClr val="black"/>
-            </a:solidFill>
-          </a:ln>
-        </p:spPr>
-        <p:txBody>
-          <a:bodyPr vert="horz" lIns="91440" tIns="45720" rIns="91440" bIns="45720" rtlCol="0" anchor="ctr"/>
-          <a:lstStyle/>
-          <a:p>
-            <a:endParaRPr lang="en-US"/>
-          </a:p>
-        </p:txBody>
-      </p:sp>
-      <p:sp>
-        <p:nvSpPr>
-          <p:cNvPr id="5" name="Notes Placeholder 4"/>
-          <p:cNvSpPr>
-            <a:spLocks noGrp="1"/>
-          </p:cNvSpPr>
-          <p:nvPr>
-            <p:ph type="body" sz="quarter" idx="3"/>
-          </p:nvPr>
-        </p:nvSpPr>
-        <p:spPr>
-          <a:xfrm>
-            <a:off x="685800" y="4400550"/>
-            <a:ext cx="5486400" cy="3600450"/>
-          </a:xfrm>
-          <a:prstGeom prst="rect">
-            <a:avLst/>
-          </a:prstGeom>
-        </p:spPr>
-        <p:txBody>
-          <a:bodyPr vert="horz" lIns="91440" tIns="45720" rIns="91440" bIns="45720" rtlCol="0"/>
-          <a:lstStyle/>
-          <a:p>
-            <a:pPr lvl="0"/>
-            <a:r>
-              <a:rPr lang="en-US"/>
-              <a:t>Click to edit Master text styles</a:t>
-            </a:r>
-          </a:p>
-          <a:p>
-            <a:pPr lvl="1"/>
-            <a:r>
-              <a:rPr lang="en-US"/>
-              <a:t>Second level</a:t>
-            </a:r>
-          </a:p>
-          <a:p>
-            <a:pPr lvl="2"/>
-            <a:r>
-              <a:rPr lang="en-US"/>
-              <a:t>Third level</a:t>
-            </a:r>
-          </a:p>
-          <a:p>
-            <a:pPr lvl="3"/>
-            <a:r>
-              <a:rPr lang="en-US"/>
-              <a:t>Fourth level</a:t>
-            </a:r>
-          </a:p>
-          <a:p>
-            <a:pPr lvl="4"/>
-            <a:r>
-              <a:rPr lang="en-US"/>
-              <a:t>Fifth level</a:t>
-            </a:r>
-          </a:p>
-        </p:txBody>
-      </p:sp>
-      <p:sp>
-        <p:nvSpPr>
-          <p:cNvPr id="6" name="Footer Placeholder 5"/>
-          <p:cNvSpPr>
-            <a:spLocks noGrp="1"/>
-          </p:cNvSpPr>
-          <p:nvPr>
-            <p:ph type="ftr" sz="quarter" idx="4"/>
-          </p:nvPr>
-        </p:nvSpPr>
-        <p:spPr>
-          <a:xfrm>
-            <a:off x="0" y="8685213"/>
-            <a:ext cx="2971800" cy="458787"/>
-          </a:xfrm>
-          <a:prstGeom prst="rect">
-            <a:avLst/>
-          </a:prstGeom>
-        </p:spPr>
-        <p:txBody>
-          <a:bodyPr vert="horz" lIns="91440" tIns="45720" rIns="91440" bIns="45720" rtlCol="0" anchor="b"/>
-          <a:lstStyle>
-            <a:lvl1pPr algn="l">
-              <a:defRPr sz="1200"/>
-            </a:lvl1pPr>
-          </a:lstStyle>
-          <a:p>
-            <a:endParaRPr lang="en-US"/>
-          </a:p>
-        </p:txBody>
-      </p:sp>
-      <p:sp>
-        <p:nvSpPr>
-          <p:cNvPr id="7" name="Slide Number Placeholder 6"/>
-          <p:cNvSpPr>
-            <a:spLocks noGrp="1"/>
-          </p:cNvSpPr>
-          <p:nvPr>
-            <p:ph type="sldNum" sz="quarter" idx="5"/>
-          </p:nvPr>
-        </p:nvSpPr>
-        <p:spPr>
-          <a:xfrm>
-            <a:off x="3884613" y="8685213"/>
-            <a:ext cx="2971800" cy="458787"/>
-          </a:xfrm>
-          <a:prstGeom prst="rect">
-            <a:avLst/>
-          </a:prstGeom>
-        </p:spPr>
-        <p:txBody>
-          <a:bodyPr vert="horz" lIns="91440" tIns="45720" rIns="91440" bIns="45720" rtlCol="0" anchor="b"/>
-          <a:lstStyle>
-            <a:lvl1pPr algn="r">
-              <a:defRPr sz="1200"/>
-            </a:lvl1pPr>
-          </a:lstStyle>
-          <a:p>
-            <a:fld id="{CE5E9CC1-C706-0F49-92D6-E571CC5EEA8F}" type="slidenum">
-              <a:rPr lang="en-US"/>
-              <a:t>‹#›</a:t>
-            </a:fld>
-            <a:endParaRPr lang="en-US"/>
-          </a:p>
-        </p:txBody>
-      </p:sp>
     </p:spTree>
     <p:extLst>
       <p:ext uri="{BB962C8B-B14F-4D97-AF65-F5344CB8AC3E}">
-        <p14:creationId xmlns:p14="http://schemas.microsoft.com/office/powerpoint/2010/main" val="1024086991"/>
+        <p14:creationId xmlns:p14="http://schemas.microsoft.com/office/powerpoint/2010/main" val="981789691"/>
       </p:ext>
     </p:extLst>
   </p:cSld>
@@ -556,7 +332,6 @@
               <a:rPr lang="en-US" dirty="0"/>
               <a:t>Buenos días. Somos el Equipo 1 del grupo 201 y trabajamos con SIMA y la Agencia de Calidad del Aire de Nuevo León. Nuestra pregunta es: ¿cuánto mejora la meteorología del día la identificación de días con PM2.5 alto en Monterrey? Ignacio empieza explicando por qué importa.</a:t>
             </a:r>
-            <a:endParaRPr lang="en-US" dirty="0"/>
           </a:p>
         </p:txBody>
       </p:sp>
@@ -644,7 +419,6 @@
               <a:rPr lang="en-US" dirty="0"/>
               <a:t>La pregunta natural de SIMA es si el PM2.5 de ayer no basta. Comparamos con la persistencia en los días que tienen dato de ayer: M0 0.712, M1 0.792, el modelo con solo PM2.5 de ayer 0.872, y con ambos 0.887. Es decir: el PM2.5 de ayer predice más que el clima del día, con una diferencia de menos 0.080. Pero el clima sí agrega sobre ayer: 0.016, con intervalo de 0.008 a 0.025. Es pequeño, pero distinguible de cero. La comparación es retrospectiva: ayer sí se conoce antes, el clima observado de hoy no. A la derecha, el umbral. Elegimos el corte con los años de validación, antes de ver la prueba, con un objetivo explícito: detectar al menos el 80 por ciento. Salió 0.182. En la prueba detecta el 84 por ciento de las superaciones, con 1.46 falsas alarmas por cada detección, y marca el 54 por ciento de los días. Es un modo de vigilancia; el corte de equilibrio, 0.262, marca menos días. Pablo expone los límites.</a:t>
             </a:r>
-            <a:endParaRPr lang="en-US" dirty="0"/>
           </a:p>
         </p:txBody>
       </p:sp>
@@ -732,7 +506,6 @@
               <a:rPr lang="en-US" dirty="0"/>
               <a:t>Queremos ser honestos con los supuestos. El LDA supone normalidad multivariada y covarianzas iguales: la prueba de Mardia y la M de Box dicen que no se cumplen, y era de esperarse con indicadoras de estación y temporada. Por eso lo usamos como clasificador lineal y no como modelo generativo bien especificado, y la evidencia es empírica: validación temporal y comparación con la logística, que da la misma conclusión; la QDA tampoco mejora. Segundo, la dependencia: los residuos siguen autocorrelacionados, 0.42 a un día. El bootstrap por bloques estima la incertidumbre respetando esa dependencia, pero no la elimina, y por eso no interpretamos los errores estándar usuales. Tercero, la prueba ya se usó en etapas anteriores. Cuarto, las exclusiones pueden sesgar. Y quinto, el análisis es retrospectivo, no pronóstico. Ignacio cierra.</a:t>
             </a:r>
-            <a:endParaRPr lang="en-US" dirty="0"/>
           </a:p>
         </p:txBody>
       </p:sp>
@@ -818,9 +591,8 @@
           <a:p>
             <a:r>
               <a:rPr lang="en-US" dirty="0"/>
-              <a:t>Respondemos la pregunta. Sí, la meteorología del día mejora la identificación, en esta medida: el AUC sube 0.079, de 0.713 a 0.792, y la detección de superaciones pasa de 56 a 74 por ciento, con intervalos que no incluyen el cero y resultados parecidos en todas las variantes, de 0.071 a 0.082. Queda débil lo siguiente: la mejora casi no aparece en lluvias, es retrospectiva porque usa clima observado, las probabilidades no están calibradas, y el PM2.5 de ayer predice más que el clima. Para SIMA recomendamos, en orden de prioridad: uno, evaluar el modelo con meteorología pronosticada, junto con su área de pronósticos; dos, incorporar las reglas de control de calidad, como radiación de madrugada y viento contra la red; y tres, revisar los sensores señalados: la radiación de García y Escobedo, y el PM2.5 de García de 2023 a 2025. Todo el código está en el repositorio, con la etiqueta informe-final; ahí está el código QR. Gracias; estamos listos para sus preguntas.</a:t>
-            </a:r>
-            <a:endParaRPr lang="en-US" dirty="0"/>
+              <a:t>Respondemos la pregunta. Sí, la meteorología del día mejora la identificación, en esta medida: el AUC sube 0.079, de 0.713 a 0.792, y la detección de superaciones pasa de 56 a 74 por ciento, con intervalos que no incluyen el cero y resultados parecidos en todas las variantes, de 0.071 a 0.082. Queda débil lo siguiente: la mejora casi no aparece en lluvias, es retrospectiva porque usa clima observado, las probabilidades no están calibradas, y el PM2.5 de ayer predice más que el clima. Para SIMA recomendamos, en orden de prioridad: uno, evaluar el modelo con meteorología pronosticada, junto con su área de pronósticos; dos, incorporar las reglas de control de calidad, como radiación de madrugada y viento contra la red; y tres, revisar los sensores señalados: la radiación de García y Escobedo, y el PM2.5 de García de 2023 a 2025. Todo el código está en el repositorio, con la etiqueta entrega-final; ahí está el código QR. Gracias; estamos listos para sus preguntas.</a:t>
+            </a:r>
           </a:p>
         </p:txBody>
       </p:sp>
@@ -908,7 +680,6 @@
               <a:rPr lang="en-US" dirty="0"/>
               <a:t>Respirar PM2.5 durante pocos días ya se asocia con efectos en la salud; un metaanálisis de 196 artículos lo respalda. Para vigilarlo usamos una referencia fija: el límite diario de 25 microgramos por metro cúbico de la NOM-025. Llamamos superación a un día-estación por encima de ese valor. Nuestra pregunta compara dos modelos. M0 solo sabe la estación y la temporada. M1 sabe lo mismo y además la meteorología del día. Lo que medimos es cuánto sube el AUC al pasar de M0 a M1, es decir, cuánto mejora la identificación de días con superación. Esto le sirve a SIMA porque es el paso previo a una alerta con pronóstico: antes de pronosticar, hay que saber si la meteorología aporta algo sobre lo que ya se conoce. Lo evaluamos en 2024 y 2025, años que el modelo no vio al ajustarse. Ahora paso a la zona de estudio.</a:t>
             </a:r>
-            <a:endParaRPr lang="en-US" dirty="0"/>
           </a:p>
         </p:txBody>
       </p:sp>
@@ -996,7 +767,6 @@
               <a:rPr lang="en-US" dirty="0"/>
               <a:t>Trabajamos con 13 estaciones del SIMA en el valle de Monterrey. En el mapa, cada círculo muestra el porcentaje de días con superación y la etiqueta da la estación y su altitud en metros. Dos cosas se ven de inmediato. Primero, no hay una relación simple con la altitud: Santa Catarina, a 674 metros, y Juárez, a 387, tienen los porcentajes más altos, 44 y 46 por ciento, y están en extremos opuestos del valle. Segundo, el viento dominante viene del este: en 11 de las 13 estaciones el viento tiene componente del este entre el 80 y el 98 por ciento de los días. SIMA nos explicó el contexto de las dos estaciones altas. Juárez es el primer receptor de la pluma de la refinería, además del crecimiento urbano. Santa Catarina tiene zona industrial y es la salida del viento del área metropolitana. Son explicaciones de SIMA; nuestro diseño no permite atribuirlas. Daniel nos presenta los datos.</a:t>
             </a:r>
-            <a:endParaRPr lang="en-US" dirty="0"/>
           </a:p>
         </p:txBody>
       </p:sp>
@@ -1084,7 +854,6 @@
               <a:rPr lang="en-US" dirty="0"/>
               <a:t>Partimos de datos horarios de 2021 a 2025 que convertimos a un registro por estación y día: 17 828 días-estación en el análisis final, con PM2.5 y ocho variables meteorológicas: temperatura, humedad, radiación, presión, viento en dos componentes y su rapidez, y horas con lluvia. A la izquierda, el porcentaje de días con superación por temporada: alrededor de 37 por ciento de noviembre a febrero, 35 de marzo a mayo y solo 11.7 en lluvias. La estación y la temporada ya dicen mucho. A la derecha, un hallazgo que guía el resto: con todos los días juntos, la temperatura es 0.3 grados menor en los días con superación; pero dentro de cada temporada es mayor, entre 0.8 y 3.3 grados. La temperatura solo se asocia con la superación cuando controlamos la temporada. Leo explica qué hicimos con los datos faltantes.</a:t>
             </a:r>
-            <a:endParaRPr lang="en-US" dirty="0"/>
           </a:p>
         </p:txBody>
       </p:sp>
@@ -1170,9 +939,8 @@
           <a:p>
             <a:r>
               <a:rPr lang="en-US" dirty="0"/>
-              <a:t>Faltaba el 12.3 por ciento de los datos, y del PM2.5 el 26 por ciento, sobre todo por apagones largos de equipos. Además invalidamos el 0.7 por ciento por inconsistencias. Tomamos tres decisiones. Una: la respuesta, el PM2.5, no se imputa. Un día cuenta solo si tiene al menos 18 horas observadas; imputar la respuesta fabricaría justo lo que queremos clasificar. Dos: la meteorología horaria se imputa con métodos del paquete imputeTS, que vimos en el curso: descomposición estacional, que repite el ciclo del día, o filtro de Kalman, según el tamaño del hueco. Para elegir el método usamos enmascaramiento: tapamos datos que sí conocemos, imputamos y medimos el error. Tres: para la meteorología diaria usamos la mediana de la red ajustada por estación, que superó a MICE, con error relativo de 0.450 frente a 0.593. El resultado es que recuperamos días: García pasa de 511 a 1 532, y en total son 2 438 días más que en la etapa anterior. También quisimos comparar con MIMA-v1, el trabajo de semestres anteriores, pero no tuvimos acceso al código y además imputa la respuesta. Pablo explica cómo analizamos.</a:t>
-            </a:r>
-            <a:endParaRPr lang="en-US" dirty="0"/>
+              <a:t>Faltaba el 12.3 por ciento de los datos, y del PM2.5 el 26 por ciento, sobre todo por apagones largos de equipos. Además invalidamos el 0.7 por ciento por inconsistencias. Tomamos tres decisiones. Una: la respuesta, el PM2.5, no se imputa. Un día cuenta solo si tiene al menos 18 horas observadas; imputar la respuesta fabricaría justo lo que queremos clasificar. Dos: la meteorología horaria se imputa con métodos del paquete imputeTS, que vimos en el curso: descomposición estacional, que repite el ciclo del día, o filtro de Kalman, según el tamaño del hueco. Para elegir el método usamos enmascaramiento: tapamos datos que sí conocemos, imputamos y medimos el error. Tres: para la meteorología diaria usamos la mediana de la red ajustada por estación, que superó a MICE, con error relativo de 0.450 frente a 0.593. El resultado es que recuperamos días: García pasa de 511 a 1 532, y en total son 2 438 días más que en la etapa anterior. También quisimos comparar con MIMA-v1, el trabajo de semestres anteriores, pero no tuvimos acceso a su dataset y además imputa la respuesta. Pablo explica cómo analizamos.</a:t>
+            </a:r>
           </a:p>
         </p:txBody>
       </p:sp>
@@ -1260,7 +1028,6 @@
               <a:rPr lang="en-US" dirty="0"/>
               <a:t>Nuestra ruta tiene cuatro pasos, y cada uno responde una pregunta. Primero, componentes principales, una técnica de interdependencia: nos dice cómo se estructura el clima. Segundo, análisis discriminante lineal y regresión logística, técnicas de dependencia: comparan M0 contra M1 para clasificar días con superación. La logística es nuestra comparación para el LDA. Tercero, validación temporal: entrenamos con 2021 a 2023 y probamos en 2024 y 2025, para saber cómo clasifica en años posteriores. Cuarto, bootstrap por bloques de 14 días, que da la incertidumbre de la mejora respetando que los días cercanos se parecen. Estación y temporada entran como variables indicadoras: 22 predictores en total, con Obispado y la temporada cálida-húmeda como referencia. Todo se ajusta solo con el entrenamiento; la prueba se usa únicamente para evaluar. Veamos el primer paso.</a:t>
             </a:r>
-            <a:endParaRPr lang="en-US" dirty="0"/>
           </a:p>
         </p:txBody>
       </p:sp>
@@ -1348,7 +1115,6 @@
               <a:rPr lang="en-US" dirty="0"/>
               <a:t>Los componentes principales resumen cómo varía el clima, medido como anomalía respecto de la media de cada estación. Tres ejes explican el 66.5 por ciento de la varianza: calor y radiación, 36 por ciento; humedad con flujo del este, 17; y presión baja con lluvia, 13. Los nombres son nuestra lectura de las cargas. La adecuación es modesta, KMO de 0.64, así que lo usamos de forma exploratoria. Y no lo usamos para predecir: el primer eje mezcla temperatura y viento, que se asocian con la superación en sentidos contrarios, y maximizar varianza no es maximizar separación entre clases. Leo presenta el resultado principal.</a:t>
             </a:r>
-            <a:endParaRPr lang="en-US" dirty="0"/>
           </a:p>
         </p:txBody>
       </p:sp>
@@ -1436,7 +1202,6 @@
               <a:rPr lang="en-US" dirty="0"/>
               <a:t>Este es el resultado principal, en la prueba de 2024 y 2025. Con LDA, el AUC pasa de 0.713 con M0 a 0.792 con M1. Con regresión logística, de 0.721 a 0.792. La mejora, ΔAUC, es de 0.079 con intervalo de 95 por ciento de 0.054 a 0.104 para el LDA, y 0.071, de 0.047 a 0.095, para la logística. Ningún intervalo incluye el cero. En términos concretos, M1 detecta el 74 por ciento de los días-estación con superación, contra 56 por ciento de M0. La especificidad casi no cambia: 0.68 frente a 0.70. Una aclaración importante: el AUC no es un porcentaje de aciertos. Es la probabilidad de que, si tomamos al azar un día con superación y uno sin superación, el modelo le dé el puntaje más alto al que sí superó. Con 0.5 sería azar y con 1, perfecto. Las curvas muestran que la naranja, M1, queda por encima de la azul en casi todo el recorrido; los círculos marcan el corte de 0.259. Los intervalos salen de un bootstrap por bloques de 14 días con 1 000 réplicas. Daniel explica cuándo mejora más.</a:t>
             </a:r>
-            <a:endParaRPr lang="en-US" dirty="0"/>
           </a:p>
         </p:txBody>
       </p:sp>
@@ -1524,7 +1289,6 @@
               <a:rPr lang="en-US" dirty="0"/>
               <a:t>La mejora no es pareja. Por temporada, de marzo a mayo el ΔAUC es de 0.151, con intervalo de 0.102 a 0.193: ahí la temporada por sí sola dice poco y el clima ayuda más. De noviembre a febrero es 0.069. En lluvias, 0.039, y su intervalo incluye el cero, así que no se distingue de cero; en esa temporada solo el 9.7 por ciento de los días supera. A la derecha, la regresión logística: odds ratios por cada desviación estándar, solo para variables cuyo signo se mantiene en el bootstrap. Con las demás variables constantes, viento más débil, presión más baja de lo normal para ese sitio y más temperatura se asocian con superación: un viento más fuerte tiene odds ratio de 0.49, una presión más alta, 0.58, y más temperatura, 1.78. Radiación y lluvia también tienen signo estable, pero pesan poco. Y una advertencia: es asociación, no causa, y no interpretamos humedad ni las componentes u y v, cuyo signo no es estable. Ahora vemos si el clima le gana al PM2.5 de ayer.</a:t>
             </a:r>
-            <a:endParaRPr lang="en-US" dirty="0"/>
           </a:p>
         </p:txBody>
       </p:sp>
@@ -1600,7 +1364,7 @@
     <p:bg>
       <p:bgPr>
         <a:blipFill dpi="0" rotWithShape="1">
-          <a:blip r:embed="rId1">
+          <a:blip r:embed="rId2">
             <a:lum/>
           </a:blip>
           <a:srcRect/>
@@ -1639,7 +1403,7 @@
     <p:bg>
       <p:bgPr>
         <a:blipFill dpi="0" rotWithShape="1">
-          <a:blip r:embed="rId1">
+          <a:blip r:embed="rId2">
             <a:lum/>
           </a:blip>
           <a:srcRect/>
@@ -1667,9 +1431,11 @@
       <p:sp>
         <p:nvSpPr>
           <p:cNvPr id="2" name="Text 0"/>
-          <p:cNvSpPr/>
+          <p:cNvSpPr>
+            <a:spLocks noGrp="1"/>
+          </p:cNvSpPr>
           <p:nvPr>
-            <p:ph idx="100" type="title" hasCustomPrompt="1"/>
+            <p:ph type="title" idx="100" hasCustomPrompt="1"/>
           </p:nvPr>
         </p:nvSpPr>
         <p:spPr>
@@ -1686,7 +1452,7 @@
         <p:txBody>
           <a:bodyPr wrap="square" rtlCol="0"/>
           <a:lstStyle>
-            <a:lvl1pPr algn="l" indent="0" marL="0">
+            <a:lvl1pPr marL="0" indent="0" algn="l">
               <a:buNone/>
               <a:defRPr lang="en-US" sz="3200" b="1" dirty="0">
                 <a:solidFill>
@@ -1699,7 +1465,7 @@
             </a:lvl1pPr>
           </a:lstStyle>
           <a:p>
-            <a:pPr algn="l" indent="0" marL="0">
+            <a:pPr marL="0" indent="0" algn="l">
               <a:buNone/>
             </a:pPr>
             <a:endParaRPr lang="en-US" sz="3200" dirty="0"/>
@@ -1726,7 +1492,7 @@
           </a:prstGeom>
           <a:extLst>
             <a:ext uri="{C572A759-6A51-4108-AA02-DFA0A04FC94B}">
-              <ma14:wrappingTextBoxFlag xmlns:ma14="http://schemas.microsoft.com/office/mac/drawingml/2011/main" val="0"/>
+              <ma14:wrappingTextBoxFlag xmlns:ma14="http://schemas.microsoft.com/office/mac/drawingml/2011/main" xmlns="" val="0"/>
             </a:ext>
           </a:extLst>
         </p:spPr>
@@ -1747,8 +1513,8 @@
           <a:p>
             <a:pPr algn="r"/>
             <a:fld id="{F7021451-1387-4CA6-816F-3879F97B5CBC}" type="slidenum">
-              <a:rPr b="0" lang="en-US"/>
-              <a:t>1003</a:t>
+              <a:rPr lang="en-US" b="0"/>
+              <a:t>‹#›</a:t>
             </a:fld>
             <a:endParaRPr lang="en-US"/>
           </a:p>
@@ -1765,6 +1531,11 @@
 <file path=ppt/slideMasters/slideMaster1.xml><?xml version="1.0" encoding="utf-8"?>
 <p:sldMaster xmlns:a="http://schemas.openxmlformats.org/drawingml/2006/main" xmlns:r="http://schemas.openxmlformats.org/officeDocument/2006/relationships" xmlns:p="http://schemas.openxmlformats.org/presentationml/2006/main">
   <p:cSld>
+    <p:bg>
+      <p:bgRef idx="1001">
+        <a:schemeClr val="bg1"/>
+      </p:bgRef>
+    </p:bg>
     <p:spTree>
       <p:nvGrpSpPr>
         <p:cNvPr id="1" name=""/>
@@ -1799,7 +1570,7 @@
           </a:prstGeom>
           <a:extLst>
             <a:ext uri="{C572A759-6A51-4108-AA02-DFA0A04FC94B}">
-              <ma14:wrappingTextBoxFlag xmlns:ma14="http://schemas.microsoft.com/office/mac/drawingml/2011/main" val="0"/>
+              <ma14:wrappingTextBoxFlag xmlns:ma14="http://schemas.microsoft.com/office/mac/drawingml/2011/main" xmlns="" val="0"/>
             </a:ext>
           </a:extLst>
         </p:spPr>
@@ -1820,8 +1591,8 @@
           <a:p>
             <a:pPr algn="r"/>
             <a:fld id="{F7021451-1387-4CA6-816F-3879F97B5CBC}" type="slidenum">
-              <a:rPr b="0" lang="en-US"/>
-              <a:t>null</a:t>
+              <a:rPr lang="en-US" b="0"/>
+              <a:t>‹#›</a:t>
             </a:fld>
             <a:endParaRPr lang="en-US"/>
           </a:p>
@@ -2132,7 +1903,7 @@
             <a:prstDash val="solid"/>
           </a:ln>
           <a:effectLst>
-            <a:outerShdw sx="100000" sy="100000" kx="0" ky="0" algn="bl" rotWithShape="0" blurRad="101600" dist="25400" dir="5400000">
+            <a:outerShdw blurRad="101600" dist="25400" dir="5400000" algn="bl" rotWithShape="0">
               <a:srgbClr val="7FB8D6">
                 <a:alpha val="25000"/>
               </a:srgbClr>
@@ -2211,7 +1982,7 @@
           <a:bodyPr wrap="square" lIns="508" tIns="508" rIns="508" bIns="508" rtlCol="0" anchor="ctr"/>
           <a:lstStyle/>
           <a:p>
-            <a:pPr algn="ctr" indent="0" marL="0">
+            <a:pPr marL="0" indent="0" algn="ctr">
               <a:buNone/>
             </a:pPr>
             <a:r>
@@ -2250,7 +2021,7 @@
           <a:bodyPr wrap="square" lIns="508" tIns="508" rIns="508" bIns="508" rtlCol="0" anchor="ctr"/>
           <a:lstStyle/>
           <a:p>
-            <a:pPr algn="ctr" indent="0" marL="0">
+            <a:pPr marL="0" indent="0" algn="ctr">
               <a:buNone/>
             </a:pPr>
             <a:r>
@@ -2289,7 +2060,7 @@
           <a:bodyPr wrap="square" lIns="508" tIns="508" rIns="508" bIns="508" rtlCol="0" anchor="ctr"/>
           <a:lstStyle/>
           <a:p>
-            <a:pPr algn="ctr" indent="0" marL="0">
+            <a:pPr marL="0" indent="0" algn="ctr">
               <a:buNone/>
             </a:pPr>
             <a:r>
@@ -2328,7 +2099,7 @@
           <a:bodyPr wrap="square" lIns="508" tIns="508" rIns="508" bIns="508" rtlCol="0" anchor="ctr"/>
           <a:lstStyle/>
           <a:p>
-            <a:pPr algn="ctr" indent="0" marL="0">
+            <a:pPr marL="0" indent="0" algn="ctr">
               <a:buNone/>
             </a:pPr>
             <a:r>
@@ -2374,9 +2145,11 @@
       <p:sp>
         <p:nvSpPr>
           <p:cNvPr id="2" name="Text 0"/>
-          <p:cNvSpPr/>
+          <p:cNvSpPr>
+            <a:spLocks noGrp="1"/>
+          </p:cNvSpPr>
           <p:nvPr>
-            <p:ph idx="100" type="title" hasCustomPrompt="1"/>
+            <p:ph type="title" idx="100" hasCustomPrompt="1"/>
           </p:nvPr>
         </p:nvSpPr>
         <p:spPr>
@@ -2394,7 +2167,7 @@
           <a:bodyPr wrap="square" lIns="0" tIns="0" rIns="0" bIns="0" rtlCol="0" anchor="ctr"/>
           <a:lstStyle/>
           <a:p>
-            <a:pPr algn="l" indent="0" marL="0">
+            <a:pPr marL="0" indent="0" algn="l">
               <a:buNone/>
             </a:pPr>
             <a:r>
@@ -2485,7 +2258,7 @@
           <a:bodyPr wrap="square" lIns="0" tIns="0" rIns="0" bIns="0" rtlCol="0" anchor="ctr"/>
           <a:lstStyle/>
           <a:p>
-            <a:pPr indent="0" marL="0">
+            <a:pPr marL="0" indent="0">
               <a:buNone/>
             </a:pPr>
             <a:r>
@@ -2529,7 +2302,7 @@
             <a:prstDash val="solid"/>
           </a:ln>
           <a:effectLst>
-            <a:outerShdw sx="100000" sy="100000" kx="0" ky="0" algn="bl" rotWithShape="0" blurRad="101600" dist="25400" dir="5400000">
+            <a:outerShdw blurRad="101600" dist="25400" dir="5400000" algn="bl" rotWithShape="0">
               <a:srgbClr val="7FB8D6">
                 <a:alpha val="25000"/>
               </a:srgbClr>
@@ -2558,7 +2331,7 @@
           <a:bodyPr wrap="square" lIns="508" tIns="508" rIns="508" bIns="508" rtlCol="0" anchor="t"/>
           <a:lstStyle/>
           <a:p>
-            <a:pPr indent="0" marL="0">
+            <a:pPr marL="0" indent="0">
               <a:buNone/>
             </a:pPr>
             <a:r>
@@ -2578,14 +2351,14 @@
       </p:sp>
       <p:pic>
         <p:nvPicPr>
-          <p:cNvPr id="8" name="pres_persistencia.png" descr="AUC de M0, M1, MP y MP1 en la prueba">    </p:cNvPr>
+          <p:cNvPr id="8" name="pres_persistencia.png" descr="AUC de M0, M1, MP y MP1 en la prueba"/>
           <p:cNvPicPr>
             <a:picLocks noChangeAspect="1"/>
           </p:cNvPicPr>
           <p:nvPr/>
         </p:nvPicPr>
         <p:blipFill>
-          <a:blip r:embed="rId1"/>
+          <a:blip r:embed="rId3"/>
           <a:stretch>
             <a:fillRect/>
           </a:stretch>
@@ -2621,7 +2394,7 @@
           <a:bodyPr wrap="square" lIns="508" tIns="508" rIns="508" bIns="508" rtlCol="0" anchor="t"/>
           <a:lstStyle/>
           <a:p>
-            <a:pPr indent="0" marL="0">
+            <a:pPr marL="0" indent="0">
               <a:buNone/>
             </a:pPr>
             <a:r>
@@ -2635,9 +2408,6 @@
               </a:rPr>
               <a:t>Ayer pesa más que el clima: </a:t>
             </a:r>
-            <a:pPr indent="0" marL="0">
-              <a:buNone/>
-            </a:pPr>
             <a:r>
               <a:rPr lang="en-US" sz="2000" dirty="0">
                 <a:solidFill>
@@ -2679,7 +2449,7 @@
             <a:prstDash val="solid"/>
           </a:ln>
           <a:effectLst>
-            <a:outerShdw sx="100000" sy="100000" kx="0" ky="0" algn="bl" rotWithShape="0" blurRad="101600" dist="25400" dir="5400000">
+            <a:outerShdw blurRad="101600" dist="25400" dir="5400000" algn="bl" rotWithShape="0">
               <a:srgbClr val="7FB8D6">
                 <a:alpha val="25000"/>
               </a:srgbClr>
@@ -2708,7 +2478,7 @@
           <a:bodyPr wrap="square" lIns="508" tIns="508" rIns="508" bIns="508" rtlCol="0" anchor="t"/>
           <a:lstStyle/>
           <a:p>
-            <a:pPr indent="0" marL="0">
+            <a:pPr marL="0" indent="0">
               <a:buNone/>
             </a:pPr>
             <a:r>
@@ -2728,14 +2498,14 @@
       </p:sp>
       <p:pic>
         <p:nvPicPr>
-          <p:cNvPr id="12" name="pres_umbral.png" descr="Sensibilidad, especificidad y valor predictivo positivo según el corte">    </p:cNvPr>
+          <p:cNvPr id="12" name="pres_umbral.png" descr="Sensibilidad, especificidad y valor predictivo positivo según el corte"/>
           <p:cNvPicPr>
             <a:picLocks noChangeAspect="1"/>
           </p:cNvPicPr>
           <p:nvPr/>
         </p:nvPicPr>
         <p:blipFill>
-          <a:blip r:embed="rId2"/>
+          <a:blip r:embed="rId4"/>
           <a:stretch>
             <a:fillRect/>
           </a:stretch>
@@ -2771,7 +2541,7 @@
           <a:bodyPr wrap="square" lIns="508" tIns="508" rIns="508" bIns="508" rtlCol="0" anchor="t"/>
           <a:lstStyle/>
           <a:p>
-            <a:pPr indent="0" marL="0">
+            <a:pPr marL="0" indent="0">
               <a:buNone/>
             </a:pPr>
             <a:r>
@@ -2785,9 +2555,6 @@
               </a:rPr>
               <a:t>Elegido en validación para detectar ≥ 80 %. </a:t>
             </a:r>
-            <a:pPr indent="0" marL="0">
-              <a:buNone/>
-            </a:pPr>
             <a:r>
               <a:rPr lang="en-US" sz="2000" dirty="0">
                 <a:solidFill>
@@ -2823,7 +2590,7 @@
           </a:prstGeom>
           <a:extLst>
             <a:ext uri="{C572A759-6A51-4108-AA02-DFA0A04FC94B}">
-              <ma14:wrappingTextBoxFlag xmlns:ma14="http://schemas.microsoft.com/office/mac/drawingml/2011/main" val="0"/>
+              <ma14:wrappingTextBoxFlag xmlns:ma14="http://schemas.microsoft.com/office/mac/drawingml/2011/main" xmlns="" val="0"/>
             </a:ext>
           </a:extLst>
         </p:spPr>
@@ -2844,7 +2611,7 @@
           <a:p>
             <a:pPr algn="r"/>
             <a:fld id="{F7021451-1387-4CA6-816F-3879F97B5CBC}" type="slidenum">
-              <a:rPr b="0" lang="en-US"/>
+              <a:rPr lang="en-US" b="0"/>
               <a:t>10</a:t>
             </a:fld>
             <a:endParaRPr lang="en-US"/>
@@ -2879,9 +2646,11 @@
       <p:sp>
         <p:nvSpPr>
           <p:cNvPr id="2" name="Text 0"/>
-          <p:cNvSpPr/>
+          <p:cNvSpPr>
+            <a:spLocks noGrp="1"/>
+          </p:cNvSpPr>
           <p:nvPr>
-            <p:ph idx="100" type="title" hasCustomPrompt="1"/>
+            <p:ph type="title" idx="100" hasCustomPrompt="1"/>
           </p:nvPr>
         </p:nvSpPr>
         <p:spPr>
@@ -2899,7 +2668,7 @@
           <a:bodyPr wrap="square" lIns="0" tIns="0" rIns="0" bIns="0" rtlCol="0" anchor="ctr"/>
           <a:lstStyle/>
           <a:p>
-            <a:pPr algn="l" indent="0" marL="0">
+            <a:pPr marL="0" indent="0" algn="l">
               <a:buNone/>
             </a:pPr>
             <a:r>
@@ -2990,7 +2759,7 @@
           <a:bodyPr wrap="square" lIns="0" tIns="0" rIns="0" bIns="0" rtlCol="0" anchor="ctr"/>
           <a:lstStyle/>
           <a:p>
-            <a:pPr indent="0" marL="0">
+            <a:pPr marL="0" indent="0">
               <a:buNone/>
             </a:pPr>
             <a:r>
@@ -3031,9 +2800,27 @@
             <a:tbl>
               <a:tblPr/>
               <a:tblGrid>
-                <a:gridCol w="2743200"/>
-                <a:gridCol w="4114800"/>
-                <a:gridCol w="4233672"/>
+                <a:gridCol w="2743200">
+                  <a:extLst>
+                    <a:ext uri="{9D8B030D-6E8A-4147-A177-3AD203B41FA5}">
+                      <a16:colId xmlns:a16="http://schemas.microsoft.com/office/drawing/2014/main" val="20000"/>
+                    </a:ext>
+                  </a:extLst>
+                </a:gridCol>
+                <a:gridCol w="4114800">
+                  <a:extLst>
+                    <a:ext uri="{9D8B030D-6E8A-4147-A177-3AD203B41FA5}">
+                      <a16:colId xmlns:a16="http://schemas.microsoft.com/office/drawing/2014/main" val="20001"/>
+                    </a:ext>
+                  </a:extLst>
+                </a:gridCol>
+                <a:gridCol w="4233672">
+                  <a:extLst>
+                    <a:ext uri="{9D8B030D-6E8A-4147-A177-3AD203B41FA5}">
+                      <a16:colId xmlns:a16="http://schemas.microsoft.com/office/drawing/2014/main" val="20002"/>
+                    </a:ext>
+                  </a:extLst>
+                </a:gridCol>
               </a:tblGrid>
               <a:tr h="502920">
                 <a:tc>
@@ -3041,7 +2828,7 @@
                     <a:bodyPr/>
                     <a:lstStyle/>
                     <a:p>
-                      <a:pPr indent="0" marL="0">
+                      <a:pPr marL="0" indent="0">
                         <a:buNone/>
                       </a:pPr>
                       <a:r>
@@ -3062,7 +2849,7 @@
                       </a:endParaRPr>
                     </a:p>
                   </a:txBody>
-                  <a:tcPr marL="109728" marR="109728" marT="45720" marB="45720" anchor="ctr">
+                  <a:tcPr marL="109728" marR="109728" anchor="ctr">
                     <a:lnL w="19050" cap="flat" cmpd="sng" algn="ctr">
                       <a:solidFill>
                         <a:schemeClr val="accent4"/>
@@ -3109,7 +2896,7 @@
                     <a:bodyPr/>
                     <a:lstStyle/>
                     <a:p>
-                      <a:pPr indent="0" marL="0">
+                      <a:pPr marL="0" indent="0">
                         <a:buNone/>
                       </a:pPr>
                       <a:r>
@@ -3130,7 +2917,7 @@
                       </a:endParaRPr>
                     </a:p>
                   </a:txBody>
-                  <a:tcPr marL="109728" marR="109728" marT="45720" marB="45720" anchor="ctr">
+                  <a:tcPr marL="109728" marR="109728" anchor="ctr">
                     <a:lnL w="19050" cap="flat" cmpd="sng" algn="ctr">
                       <a:solidFill>
                         <a:schemeClr val="accent4"/>
@@ -3177,7 +2964,7 @@
                     <a:bodyPr/>
                     <a:lstStyle/>
                     <a:p>
-                      <a:pPr indent="0" marL="0">
+                      <a:pPr marL="0" indent="0">
                         <a:buNone/>
                       </a:pPr>
                       <a:r>
@@ -3198,7 +2985,7 @@
                       </a:endParaRPr>
                     </a:p>
                   </a:txBody>
-                  <a:tcPr marL="109728" marR="109728" marT="45720" marB="45720" anchor="ctr">
+                  <a:tcPr marL="109728" marR="109728" anchor="ctr">
                     <a:lnL w="19050" cap="flat" cmpd="sng" algn="ctr">
                       <a:solidFill>
                         <a:schemeClr val="accent4"/>
@@ -3240,6 +3027,11 @@
                     </a:solidFill>
                   </a:tcPr>
                 </a:tc>
+                <a:extLst>
+                  <a:ext uri="{0D108BD9-81ED-4DB2-BD59-A6C34878D82A}">
+                    <a16:rowId xmlns:a16="http://schemas.microsoft.com/office/drawing/2014/main" val="10000"/>
+                  </a:ext>
+                </a:extLst>
               </a:tr>
               <a:tr h="868680">
                 <a:tc>
@@ -3247,7 +3039,7 @@
                     <a:bodyPr/>
                     <a:lstStyle/>
                     <a:p>
-                      <a:pPr indent="0" marL="0">
+                      <a:pPr marL="0" indent="0">
                         <a:buNone/>
                       </a:pPr>
                       <a:r>
@@ -3268,7 +3060,7 @@
                       </a:endParaRPr>
                     </a:p>
                   </a:txBody>
-                  <a:tcPr marL="109728" marR="109728" marT="45720" marB="45720" anchor="ctr">
+                  <a:tcPr marL="109728" marR="109728" anchor="ctr">
                     <a:lnL w="19050" cap="flat" cmpd="sng" algn="ctr">
                       <a:solidFill>
                         <a:schemeClr val="accent4"/>
@@ -3315,7 +3107,7 @@
                     <a:bodyPr/>
                     <a:lstStyle/>
                     <a:p>
-                      <a:pPr indent="0" marL="0">
+                      <a:pPr marL="0" indent="0">
                         <a:buNone/>
                       </a:pPr>
                       <a:r>
@@ -3336,7 +3128,7 @@
                       </a:endParaRPr>
                     </a:p>
                   </a:txBody>
-                  <a:tcPr marL="109728" marR="109728" marT="45720" marB="45720" anchor="ctr">
+                  <a:tcPr marL="109728" marR="109728" anchor="ctr">
                     <a:lnL w="19050" cap="flat" cmpd="sng" algn="ctr">
                       <a:solidFill>
                         <a:schemeClr val="accent4"/>
@@ -3383,7 +3175,7 @@
                     <a:bodyPr/>
                     <a:lstStyle/>
                     <a:p>
-                      <a:pPr indent="0" marL="0">
+                      <a:pPr marL="0" indent="0">
                         <a:buNone/>
                       </a:pPr>
                       <a:r>
@@ -3404,7 +3196,7 @@
                       </a:endParaRPr>
                     </a:p>
                   </a:txBody>
-                  <a:tcPr marL="109728" marR="109728" marT="45720" marB="45720" anchor="ctr">
+                  <a:tcPr marL="109728" marR="109728" anchor="ctr">
                     <a:lnL w="19050" cap="flat" cmpd="sng" algn="ctr">
                       <a:solidFill>
                         <a:schemeClr val="accent4"/>
@@ -3446,6 +3238,11 @@
                     </a:solidFill>
                   </a:tcPr>
                 </a:tc>
+                <a:extLst>
+                  <a:ext uri="{0D108BD9-81ED-4DB2-BD59-A6C34878D82A}">
+                    <a16:rowId xmlns:a16="http://schemas.microsoft.com/office/drawing/2014/main" val="10001"/>
+                  </a:ext>
+                </a:extLst>
               </a:tr>
               <a:tr h="868680">
                 <a:tc>
@@ -3453,7 +3250,7 @@
                     <a:bodyPr/>
                     <a:lstStyle/>
                     <a:p>
-                      <a:pPr indent="0" marL="0">
+                      <a:pPr marL="0" indent="0">
                         <a:buNone/>
                       </a:pPr>
                       <a:r>
@@ -3474,7 +3271,7 @@
                       </a:endParaRPr>
                     </a:p>
                   </a:txBody>
-                  <a:tcPr marL="109728" marR="109728" marT="45720" marB="45720" anchor="ctr">
+                  <a:tcPr marL="109728" marR="109728" anchor="ctr">
                     <a:lnL w="19050" cap="flat" cmpd="sng" algn="ctr">
                       <a:solidFill>
                         <a:schemeClr val="accent4"/>
@@ -3521,7 +3318,7 @@
                     <a:bodyPr/>
                     <a:lstStyle/>
                     <a:p>
-                      <a:pPr indent="0" marL="0">
+                      <a:pPr marL="0" indent="0">
                         <a:buNone/>
                       </a:pPr>
                       <a:r>
@@ -3542,7 +3339,7 @@
                       </a:endParaRPr>
                     </a:p>
                   </a:txBody>
-                  <a:tcPr marL="109728" marR="109728" marT="45720" marB="45720" anchor="ctr">
+                  <a:tcPr marL="109728" marR="109728" anchor="ctr">
                     <a:lnL w="19050" cap="flat" cmpd="sng" algn="ctr">
                       <a:solidFill>
                         <a:schemeClr val="accent4"/>
@@ -3589,7 +3386,7 @@
                     <a:bodyPr/>
                     <a:lstStyle/>
                     <a:p>
-                      <a:pPr indent="0" marL="0">
+                      <a:pPr marL="0" indent="0">
                         <a:buNone/>
                       </a:pPr>
                       <a:r>
@@ -3610,7 +3407,7 @@
                       </a:endParaRPr>
                     </a:p>
                   </a:txBody>
-                  <a:tcPr marL="109728" marR="109728" marT="45720" marB="45720" anchor="ctr">
+                  <a:tcPr marL="109728" marR="109728" anchor="ctr">
                     <a:lnL w="19050" cap="flat" cmpd="sng" algn="ctr">
                       <a:solidFill>
                         <a:schemeClr val="accent4"/>
@@ -3652,6 +3449,11 @@
                     </a:solidFill>
                   </a:tcPr>
                 </a:tc>
+                <a:extLst>
+                  <a:ext uri="{0D108BD9-81ED-4DB2-BD59-A6C34878D82A}">
+                    <a16:rowId xmlns:a16="http://schemas.microsoft.com/office/drawing/2014/main" val="10002"/>
+                  </a:ext>
+                </a:extLst>
               </a:tr>
               <a:tr h="868680">
                 <a:tc>
@@ -3659,7 +3461,7 @@
                     <a:bodyPr/>
                     <a:lstStyle/>
                     <a:p>
-                      <a:pPr indent="0" marL="0">
+                      <a:pPr marL="0" indent="0">
                         <a:buNone/>
                       </a:pPr>
                       <a:r>
@@ -3680,7 +3482,7 @@
                       </a:endParaRPr>
                     </a:p>
                   </a:txBody>
-                  <a:tcPr marL="109728" marR="109728" marT="45720" marB="45720" anchor="ctr">
+                  <a:tcPr marL="109728" marR="109728" anchor="ctr">
                     <a:lnL w="19050" cap="flat" cmpd="sng" algn="ctr">
                       <a:solidFill>
                         <a:schemeClr val="accent4"/>
@@ -3727,7 +3529,7 @@
                     <a:bodyPr/>
                     <a:lstStyle/>
                     <a:p>
-                      <a:pPr indent="0" marL="0">
+                      <a:pPr marL="0" indent="0">
                         <a:buNone/>
                       </a:pPr>
                       <a:r>
@@ -3748,7 +3550,7 @@
                       </a:endParaRPr>
                     </a:p>
                   </a:txBody>
-                  <a:tcPr marL="109728" marR="109728" marT="45720" marB="45720" anchor="ctr">
+                  <a:tcPr marL="109728" marR="109728" anchor="ctr">
                     <a:lnL w="19050" cap="flat" cmpd="sng" algn="ctr">
                       <a:solidFill>
                         <a:schemeClr val="accent4"/>
@@ -3795,7 +3597,7 @@
                     <a:bodyPr/>
                     <a:lstStyle/>
                     <a:p>
-                      <a:pPr indent="0" marL="0">
+                      <a:pPr marL="0" indent="0">
                         <a:buNone/>
                       </a:pPr>
                       <a:r>
@@ -3816,7 +3618,7 @@
                       </a:endParaRPr>
                     </a:p>
                   </a:txBody>
-                  <a:tcPr marL="109728" marR="109728" marT="45720" marB="45720" anchor="ctr">
+                  <a:tcPr marL="109728" marR="109728" anchor="ctr">
                     <a:lnL w="19050" cap="flat" cmpd="sng" algn="ctr">
                       <a:solidFill>
                         <a:schemeClr val="accent4"/>
@@ -3858,6 +3660,11 @@
                     </a:solidFill>
                   </a:tcPr>
                 </a:tc>
+                <a:extLst>
+                  <a:ext uri="{0D108BD9-81ED-4DB2-BD59-A6C34878D82A}">
+                    <a16:rowId xmlns:a16="http://schemas.microsoft.com/office/drawing/2014/main" val="10003"/>
+                  </a:ext>
+                </a:extLst>
               </a:tr>
               <a:tr h="868680">
                 <a:tc>
@@ -3865,7 +3672,7 @@
                     <a:bodyPr/>
                     <a:lstStyle/>
                     <a:p>
-                      <a:pPr indent="0" marL="0">
+                      <a:pPr marL="0" indent="0">
                         <a:buNone/>
                       </a:pPr>
                       <a:r>
@@ -3886,7 +3693,7 @@
                       </a:endParaRPr>
                     </a:p>
                   </a:txBody>
-                  <a:tcPr marL="109728" marR="109728" marT="45720" marB="45720" anchor="ctr">
+                  <a:tcPr marL="109728" marR="109728" anchor="ctr">
                     <a:lnL w="19050" cap="flat" cmpd="sng" algn="ctr">
                       <a:solidFill>
                         <a:schemeClr val="accent4"/>
@@ -3933,7 +3740,7 @@
                     <a:bodyPr/>
                     <a:lstStyle/>
                     <a:p>
-                      <a:pPr indent="0" marL="0">
+                      <a:pPr marL="0" indent="0">
                         <a:buNone/>
                       </a:pPr>
                       <a:r>
@@ -3954,7 +3761,7 @@
                       </a:endParaRPr>
                     </a:p>
                   </a:txBody>
-                  <a:tcPr marL="109728" marR="109728" marT="45720" marB="45720" anchor="ctr">
+                  <a:tcPr marL="109728" marR="109728" anchor="ctr">
                     <a:lnL w="19050" cap="flat" cmpd="sng" algn="ctr">
                       <a:solidFill>
                         <a:schemeClr val="accent4"/>
@@ -4001,7 +3808,7 @@
                     <a:bodyPr/>
                     <a:lstStyle/>
                     <a:p>
-                      <a:pPr indent="0" marL="0">
+                      <a:pPr marL="0" indent="0">
                         <a:buNone/>
                       </a:pPr>
                       <a:r>
@@ -4022,7 +3829,7 @@
                       </a:endParaRPr>
                     </a:p>
                   </a:txBody>
-                  <a:tcPr marL="109728" marR="109728" marT="45720" marB="45720" anchor="ctr">
+                  <a:tcPr marL="109728" marR="109728" anchor="ctr">
                     <a:lnL w="19050" cap="flat" cmpd="sng" algn="ctr">
                       <a:solidFill>
                         <a:schemeClr val="accent4"/>
@@ -4064,6 +3871,11 @@
                     </a:solidFill>
                   </a:tcPr>
                 </a:tc>
+                <a:extLst>
+                  <a:ext uri="{0D108BD9-81ED-4DB2-BD59-A6C34878D82A}">
+                    <a16:rowId xmlns:a16="http://schemas.microsoft.com/office/drawing/2014/main" val="10004"/>
+                  </a:ext>
+                </a:extLst>
               </a:tr>
               <a:tr h="868680">
                 <a:tc>
@@ -4071,7 +3883,7 @@
                     <a:bodyPr/>
                     <a:lstStyle/>
                     <a:p>
-                      <a:pPr indent="0" marL="0">
+                      <a:pPr marL="0" indent="0">
                         <a:buNone/>
                       </a:pPr>
                       <a:r>
@@ -4092,7 +3904,7 @@
                       </a:endParaRPr>
                     </a:p>
                   </a:txBody>
-                  <a:tcPr marL="109728" marR="109728" marT="45720" marB="45720" anchor="ctr">
+                  <a:tcPr marL="109728" marR="109728" anchor="ctr">
                     <a:lnL w="19050" cap="flat" cmpd="sng" algn="ctr">
                       <a:solidFill>
                         <a:schemeClr val="accent4"/>
@@ -4139,7 +3951,7 @@
                     <a:bodyPr/>
                     <a:lstStyle/>
                     <a:p>
-                      <a:pPr indent="0" marL="0">
+                      <a:pPr marL="0" indent="0">
                         <a:buNone/>
                       </a:pPr>
                       <a:r>
@@ -4160,7 +3972,7 @@
                       </a:endParaRPr>
                     </a:p>
                   </a:txBody>
-                  <a:tcPr marL="109728" marR="109728" marT="45720" marB="45720" anchor="ctr">
+                  <a:tcPr marL="109728" marR="109728" anchor="ctr">
                     <a:lnL w="19050" cap="flat" cmpd="sng" algn="ctr">
                       <a:solidFill>
                         <a:schemeClr val="accent4"/>
@@ -4207,7 +4019,7 @@
                     <a:bodyPr/>
                     <a:lstStyle/>
                     <a:p>
-                      <a:pPr indent="0" marL="0">
+                      <a:pPr marL="0" indent="0">
                         <a:buNone/>
                       </a:pPr>
                       <a:r>
@@ -4228,7 +4040,7 @@
                       </a:endParaRPr>
                     </a:p>
                   </a:txBody>
-                  <a:tcPr marL="109728" marR="109728" marT="45720" marB="45720" anchor="ctr">
+                  <a:tcPr marL="109728" marR="109728" anchor="ctr">
                     <a:lnL w="19050" cap="flat" cmpd="sng" algn="ctr">
                       <a:solidFill>
                         <a:schemeClr val="accent4"/>
@@ -4270,6 +4082,11 @@
                     </a:solidFill>
                   </a:tcPr>
                 </a:tc>
+                <a:extLst>
+                  <a:ext uri="{0D108BD9-81ED-4DB2-BD59-A6C34878D82A}">
+                    <a16:rowId xmlns:a16="http://schemas.microsoft.com/office/drawing/2014/main" val="10005"/>
+                  </a:ext>
+                </a:extLst>
               </a:tr>
             </a:tbl>
           </a:graphicData>
@@ -4295,7 +4112,7 @@
           </a:prstGeom>
           <a:extLst>
             <a:ext uri="{C572A759-6A51-4108-AA02-DFA0A04FC94B}">
-              <ma14:wrappingTextBoxFlag xmlns:ma14="http://schemas.microsoft.com/office/mac/drawingml/2011/main" val="0"/>
+              <ma14:wrappingTextBoxFlag xmlns:ma14="http://schemas.microsoft.com/office/mac/drawingml/2011/main" xmlns="" val="0"/>
             </a:ext>
           </a:extLst>
         </p:spPr>
@@ -4316,7 +4133,7 @@
           <a:p>
             <a:pPr algn="r"/>
             <a:fld id="{F7021451-1387-4CA6-816F-3879F97B5CBC}" type="slidenum">
-              <a:rPr b="0" lang="en-US"/>
+              <a:rPr lang="en-US" b="0"/>
               <a:t>11</a:t>
             </a:fld>
             <a:endParaRPr lang="en-US"/>
@@ -4351,9 +4168,11 @@
       <p:sp>
         <p:nvSpPr>
           <p:cNvPr id="2" name="Text 0"/>
-          <p:cNvSpPr/>
+          <p:cNvSpPr>
+            <a:spLocks noGrp="1"/>
+          </p:cNvSpPr>
           <p:nvPr>
-            <p:ph idx="100" type="title" hasCustomPrompt="1"/>
+            <p:ph type="title" idx="100" hasCustomPrompt="1"/>
           </p:nvPr>
         </p:nvSpPr>
         <p:spPr>
@@ -4371,7 +4190,7 @@
           <a:bodyPr wrap="square" lIns="0" tIns="0" rIns="0" bIns="0" rtlCol="0" anchor="ctr"/>
           <a:lstStyle/>
           <a:p>
-            <a:pPr algn="l" indent="0" marL="0">
+            <a:pPr marL="0" indent="0" algn="l">
               <a:buNone/>
             </a:pPr>
             <a:r>
@@ -4462,7 +4281,7 @@
           <a:bodyPr wrap="square" lIns="0" tIns="0" rIns="0" bIns="0" rtlCol="0" anchor="ctr"/>
           <a:lstStyle/>
           <a:p>
-            <a:pPr indent="0" marL="0">
+            <a:pPr marL="0" indent="0">
               <a:buNone/>
             </a:pPr>
             <a:r>
@@ -4506,7 +4325,7 @@
             <a:prstDash val="solid"/>
           </a:ln>
           <a:effectLst>
-            <a:outerShdw sx="100000" sy="100000" kx="0" ky="0" algn="bl" rotWithShape="0" blurRad="101600" dist="25400" dir="5400000">
+            <a:outerShdw blurRad="101600" dist="25400" dir="5400000" algn="bl" rotWithShape="0">
               <a:srgbClr val="7FB8D6">
                 <a:alpha val="25000"/>
               </a:srgbClr>
@@ -4562,7 +4381,7 @@
           <a:bodyPr wrap="square" lIns="508" tIns="508" rIns="508" bIns="508" rtlCol="0" anchor="ctr"/>
           <a:lstStyle/>
           <a:p>
-            <a:pPr indent="0" marL="0">
+            <a:pPr marL="0" indent="0">
               <a:buNone/>
             </a:pPr>
             <a:r>
@@ -4601,7 +4420,7 @@
           <a:bodyPr wrap="square" lIns="0" tIns="0" rIns="0" bIns="0" rtlCol="0" anchor="ctr"/>
           <a:lstStyle/>
           <a:p>
-            <a:pPr indent="0" marL="0">
+            <a:pPr marL="0" indent="0">
               <a:buNone/>
             </a:pPr>
             <a:r>
@@ -4615,9 +4434,6 @@
               </a:rPr>
               <a:t>0.713</a:t>
             </a:r>
-            <a:pPr indent="0" marL="0">
-              <a:buNone/>
-            </a:pPr>
             <a:r>
               <a:rPr lang="en-US" sz="2800" b="1" dirty="0">
                 <a:solidFill>
@@ -4629,9 +4445,6 @@
               </a:rPr>
               <a:t> → </a:t>
             </a:r>
-            <a:pPr indent="0" marL="0">
-              <a:buNone/>
-            </a:pPr>
             <a:r>
               <a:rPr lang="en-US" sz="4400" b="1" dirty="0">
                 <a:solidFill>
@@ -4668,7 +4481,7 @@
           <a:bodyPr wrap="square" lIns="508" tIns="508" rIns="508" bIns="508" rtlCol="0" anchor="t"/>
           <a:lstStyle/>
           <a:p>
-            <a:pPr indent="0" marL="0">
+            <a:pPr marL="0" indent="0">
               <a:buNone/>
             </a:pPr>
             <a:r>
@@ -4734,7 +4547,7 @@
           <a:bodyPr wrap="square" lIns="508" tIns="508" rIns="508" bIns="508" rtlCol="0" anchor="ctr"/>
           <a:lstStyle/>
           <a:p>
-            <a:pPr indent="0" marL="0">
+            <a:pPr marL="0" indent="0">
               <a:buNone/>
             </a:pPr>
             <a:r>
@@ -4884,7 +4697,7 @@
             <a:prstDash val="solid"/>
           </a:ln>
           <a:effectLst>
-            <a:outerShdw sx="100000" sy="100000" kx="0" ky="0" algn="bl" rotWithShape="0" blurRad="101600" dist="25400" dir="5400000">
+            <a:outerShdw blurRad="101600" dist="25400" dir="5400000" algn="bl" rotWithShape="0">
               <a:srgbClr val="7FB8D6">
                 <a:alpha val="25000"/>
               </a:srgbClr>
@@ -4938,7 +4751,7 @@
           <a:bodyPr wrap="square" lIns="0" tIns="0" rIns="0" bIns="0" rtlCol="0" anchor="ctr"/>
           <a:lstStyle/>
           <a:p>
-            <a:pPr algn="ctr" indent="0" marL="0">
+            <a:pPr marL="0" indent="0" algn="ctr">
               <a:buNone/>
             </a:pPr>
             <a:r>
@@ -4977,7 +4790,7 @@
           <a:bodyPr wrap="square" lIns="508" tIns="508" rIns="508" bIns="508" rtlCol="0" anchor="ctr"/>
           <a:lstStyle/>
           <a:p>
-            <a:pPr indent="0" marL="0">
+            <a:pPr marL="0" indent="0">
               <a:buNone/>
             </a:pPr>
             <a:r>
@@ -5021,7 +4834,7 @@
             <a:prstDash val="solid"/>
           </a:ln>
           <a:effectLst>
-            <a:outerShdw sx="100000" sy="100000" kx="0" ky="0" algn="bl" rotWithShape="0" blurRad="101600" dist="25400" dir="5400000">
+            <a:outerShdw blurRad="101600" dist="25400" dir="5400000" algn="bl" rotWithShape="0">
               <a:srgbClr val="7FB8D6">
                 <a:alpha val="25000"/>
               </a:srgbClr>
@@ -5075,7 +4888,7 @@
           <a:bodyPr wrap="square" lIns="0" tIns="0" rIns="0" bIns="0" rtlCol="0" anchor="ctr"/>
           <a:lstStyle/>
           <a:p>
-            <a:pPr algn="ctr" indent="0" marL="0">
+            <a:pPr marL="0" indent="0" algn="ctr">
               <a:buNone/>
             </a:pPr>
             <a:r>
@@ -5114,7 +4927,7 @@
           <a:bodyPr wrap="square" lIns="508" tIns="508" rIns="508" bIns="508" rtlCol="0" anchor="ctr"/>
           <a:lstStyle/>
           <a:p>
-            <a:pPr indent="0" marL="0">
+            <a:pPr marL="0" indent="0">
               <a:buNone/>
             </a:pPr>
             <a:r>
@@ -5158,7 +4971,7 @@
             <a:prstDash val="solid"/>
           </a:ln>
           <a:effectLst>
-            <a:outerShdw sx="100000" sy="100000" kx="0" ky="0" algn="bl" rotWithShape="0" blurRad="101600" dist="25400" dir="5400000">
+            <a:outerShdw blurRad="101600" dist="25400" dir="5400000" algn="bl" rotWithShape="0">
               <a:srgbClr val="7FB8D6">
                 <a:alpha val="25000"/>
               </a:srgbClr>
@@ -5212,7 +5025,7 @@
           <a:bodyPr wrap="square" lIns="0" tIns="0" rIns="0" bIns="0" rtlCol="0" anchor="ctr"/>
           <a:lstStyle/>
           <a:p>
-            <a:pPr algn="ctr" indent="0" marL="0">
+            <a:pPr marL="0" indent="0" algn="ctr">
               <a:buNone/>
             </a:pPr>
             <a:r>
@@ -5251,7 +5064,7 @@
           <a:bodyPr wrap="square" lIns="508" tIns="508" rIns="508" bIns="508" rtlCol="0" anchor="ctr"/>
           <a:lstStyle/>
           <a:p>
-            <a:pPr indent="0" marL="0">
+            <a:pPr marL="0" indent="0">
               <a:buNone/>
             </a:pPr>
             <a:r>
@@ -5295,7 +5108,7 @@
             <a:prstDash val="solid"/>
           </a:ln>
           <a:effectLst>
-            <a:outerShdw sx="100000" sy="100000" kx="0" ky="0" algn="bl" rotWithShape="0" blurRad="101600" dist="25400" dir="5400000">
+            <a:outerShdw blurRad="101600" dist="25400" dir="5400000" algn="bl" rotWithShape="0">
               <a:srgbClr val="7FB8D6">
                 <a:alpha val="25000"/>
               </a:srgbClr>
@@ -5305,14 +5118,14 @@
       </p:sp>
       <p:pic>
         <p:nvPicPr>
-          <p:cNvPr id="27" name="QR" descr="Código QR del repositorio, etiqueta informe-final">    </p:cNvPr>
+          <p:cNvPr id="27" name="QR" descr="Código QR del repositorio, etiqueta informe-final"/>
           <p:cNvPicPr>
             <a:picLocks noChangeAspect="1"/>
           </p:cNvPicPr>
           <p:nvPr/>
         </p:nvPicPr>
         <p:blipFill>
-          <a:blip r:embed="rId1"/>
+          <a:blip r:embed="rId3"/>
           <a:stretch>
             <a:fillRect/>
           </a:stretch>
@@ -5348,7 +5161,7 @@
           <a:bodyPr wrap="square" lIns="508" tIns="508" rIns="508" bIns="508" rtlCol="0" anchor="ctr"/>
           <a:lstStyle/>
           <a:p>
-            <a:pPr indent="0" marL="0">
+            <a:pPr marL="0" indent="0">
               <a:buNone/>
             </a:pPr>
             <a:r>
@@ -5365,7 +5178,7 @@
             <a:endParaRPr lang="en-US" sz="2000" dirty="0"/>
           </a:p>
           <a:p>
-            <a:pPr indent="0" marL="0">
+            <a:pPr marL="0" indent="0">
               <a:buNone/>
             </a:pPr>
             <a:r>
@@ -5377,7 +5190,7 @@
                 <a:ea typeface="Calibri" pitchFamily="34" charset="-122"/>
                 <a:cs typeface="Calibri" pitchFamily="34" charset="-120"/>
               </a:rPr>
-              <a:t>github.com/Leo-issacs/reto-sima-multivariados · etiqueta informe-final</a:t>
+              <a:t>github.com/Leo-issacs/reto-sima-multivariados · etiqueta entrega-final</a:t>
             </a:r>
             <a:endParaRPr lang="en-US" sz="2000" dirty="0"/>
           </a:p>
@@ -5385,7 +5198,7 @@
       </p:sp>
       <p:sp>
         <p:nvSpPr>
-          <p:cNvPr id="25" name="Slide Number Placeholder 0"/>
+          <p:cNvPr id="29" name="Slide Number Placeholder 0"/>
           <p:cNvSpPr>
             <a:spLocks noGrp="1"/>
           </p:cNvSpPr>
@@ -5403,7 +5216,7 @@
           </a:prstGeom>
           <a:extLst>
             <a:ext uri="{C572A759-6A51-4108-AA02-DFA0A04FC94B}">
-              <ma14:wrappingTextBoxFlag xmlns:ma14="http://schemas.microsoft.com/office/mac/drawingml/2011/main" val="0"/>
+              <ma14:wrappingTextBoxFlag xmlns:ma14="http://schemas.microsoft.com/office/mac/drawingml/2011/main" xmlns="" val="0"/>
             </a:ext>
           </a:extLst>
         </p:spPr>
@@ -5424,7 +5237,7 @@
           <a:p>
             <a:pPr algn="r"/>
             <a:fld id="{F7021451-1387-4CA6-816F-3879F97B5CBC}" type="slidenum">
-              <a:rPr b="0" lang="en-US"/>
+              <a:rPr lang="en-US" b="0"/>
               <a:t>12</a:t>
             </a:fld>
             <a:endParaRPr lang="en-US"/>
@@ -5459,9 +5272,11 @@
       <p:sp>
         <p:nvSpPr>
           <p:cNvPr id="2" name="Text 0"/>
-          <p:cNvSpPr/>
+          <p:cNvSpPr>
+            <a:spLocks noGrp="1"/>
+          </p:cNvSpPr>
           <p:nvPr>
-            <p:ph idx="100" type="title" hasCustomPrompt="1"/>
+            <p:ph type="title" idx="100" hasCustomPrompt="1"/>
           </p:nvPr>
         </p:nvSpPr>
         <p:spPr>
@@ -5479,7 +5294,7 @@
           <a:bodyPr wrap="square" lIns="0" tIns="0" rIns="0" bIns="0" rtlCol="0" anchor="ctr"/>
           <a:lstStyle/>
           <a:p>
-            <a:pPr algn="l" indent="0" marL="0">
+            <a:pPr marL="0" indent="0" algn="l">
               <a:buNone/>
             </a:pPr>
             <a:r>
@@ -5570,7 +5385,7 @@
           <a:bodyPr wrap="square" lIns="0" tIns="0" rIns="0" bIns="0" rtlCol="0" anchor="ctr"/>
           <a:lstStyle/>
           <a:p>
-            <a:pPr indent="0" marL="0">
+            <a:pPr marL="0" indent="0">
               <a:buNone/>
             </a:pPr>
             <a:r>
@@ -5614,7 +5429,7 @@
             <a:prstDash val="solid"/>
           </a:ln>
           <a:effectLst>
-            <a:outerShdw sx="100000" sy="100000" kx="0" ky="0" algn="bl" rotWithShape="0" blurRad="101600" dist="25400" dir="5400000">
+            <a:outerShdw blurRad="101600" dist="25400" dir="5400000" algn="bl" rotWithShape="0">
               <a:srgbClr val="7FB8D6">
                 <a:alpha val="25000"/>
               </a:srgbClr>
@@ -5643,7 +5458,7 @@
           <a:bodyPr wrap="square" lIns="508" tIns="508" rIns="508" bIns="508" rtlCol="0" anchor="t"/>
           <a:lstStyle/>
           <a:p>
-            <a:pPr indent="0" marL="0">
+            <a:pPr marL="0" indent="0">
               <a:buNone/>
             </a:pPr>
             <a:r>
@@ -5682,7 +5497,7 @@
           <a:bodyPr wrap="square" lIns="508" tIns="508" rIns="508" bIns="508" rtlCol="0" anchor="t"/>
           <a:lstStyle/>
           <a:p>
-            <a:pPr indent="0" marL="0">
+            <a:pPr marL="0" indent="0">
               <a:buNone/>
             </a:pPr>
             <a:r>
@@ -5726,7 +5541,7 @@
             <a:prstDash val="solid"/>
           </a:ln>
           <a:effectLst>
-            <a:outerShdw sx="100000" sy="100000" kx="0" ky="0" algn="bl" rotWithShape="0" blurRad="101600" dist="25400" dir="5400000">
+            <a:outerShdw blurRad="101600" dist="25400" dir="5400000" algn="bl" rotWithShape="0">
               <a:srgbClr val="7FB8D6">
                 <a:alpha val="25000"/>
               </a:srgbClr>
@@ -5755,7 +5570,7 @@
           <a:bodyPr wrap="square" lIns="508" tIns="508" rIns="508" bIns="508" rtlCol="0" anchor="ctr"/>
           <a:lstStyle/>
           <a:p>
-            <a:pPr indent="0" marL="0">
+            <a:pPr marL="0" indent="0">
               <a:buNone/>
             </a:pPr>
             <a:r>
@@ -5794,7 +5609,7 @@
           <a:bodyPr wrap="square" lIns="508" tIns="508" rIns="508" bIns="508" rtlCol="0" anchor="ctr"/>
           <a:lstStyle/>
           <a:p>
-            <a:pPr indent="0" marL="0">
+            <a:pPr marL="0" indent="0">
               <a:buNone/>
             </a:pPr>
             <a:r>
@@ -5811,7 +5626,7 @@
             <a:endParaRPr lang="en-US" sz="2000" dirty="0"/>
           </a:p>
           <a:p>
-            <a:pPr indent="0" marL="0">
+            <a:pPr marL="0" indent="0">
               <a:buNone/>
             </a:pPr>
             <a:r>
@@ -5855,7 +5670,7 @@
             <a:prstDash val="solid"/>
           </a:ln>
           <a:effectLst>
-            <a:outerShdw sx="100000" sy="100000" kx="0" ky="0" algn="bl" rotWithShape="0" blurRad="101600" dist="25400" dir="5400000">
+            <a:outerShdw blurRad="101600" dist="25400" dir="5400000" algn="bl" rotWithShape="0">
               <a:srgbClr val="7FB8D6">
                 <a:alpha val="25000"/>
               </a:srgbClr>
@@ -5884,7 +5699,7 @@
           <a:bodyPr wrap="square" lIns="508" tIns="508" rIns="508" bIns="508" rtlCol="0" anchor="t"/>
           <a:lstStyle/>
           <a:p>
-            <a:pPr indent="0" marL="0">
+            <a:pPr marL="0" indent="0">
               <a:buNone/>
             </a:pPr>
             <a:r>
@@ -5923,7 +5738,7 @@
           <a:bodyPr wrap="square" lIns="508" tIns="508" rIns="508" bIns="508" rtlCol="0" anchor="t"/>
           <a:lstStyle/>
           <a:p>
-            <a:pPr indent="0" marL="0">
+            <a:pPr marL="0" indent="0">
               <a:buNone/>
             </a:pPr>
             <a:r>
@@ -5967,7 +5782,7 @@
             <a:prstDash val="solid"/>
           </a:ln>
           <a:effectLst>
-            <a:outerShdw sx="100000" sy="100000" kx="0" ky="0" algn="bl" rotWithShape="0" blurRad="101600" dist="25400" dir="5400000">
+            <a:outerShdw blurRad="101600" dist="25400" dir="5400000" algn="bl" rotWithShape="0">
               <a:srgbClr val="7FB8D6">
                 <a:alpha val="25000"/>
               </a:srgbClr>
@@ -5996,7 +5811,7 @@
           <a:bodyPr wrap="square" lIns="508" tIns="508" rIns="508" bIns="508" rtlCol="0" anchor="t"/>
           <a:lstStyle/>
           <a:p>
-            <a:pPr indent="0" marL="0">
+            <a:pPr marL="0" indent="0">
               <a:buNone/>
             </a:pPr>
             <a:r>
@@ -6062,7 +5877,7 @@
           <a:bodyPr wrap="square" lIns="508" tIns="508" rIns="508" bIns="508" rtlCol="0" anchor="ctr"/>
           <a:lstStyle/>
           <a:p>
-            <a:pPr indent="0" marL="0">
+            <a:pPr marL="0" indent="0">
               <a:buNone/>
             </a:pPr>
             <a:r>
@@ -6076,9 +5891,6 @@
               </a:rPr>
               <a:t>M0  </a:t>
             </a:r>
-            <a:pPr indent="0" marL="0">
-              <a:buNone/>
-            </a:pPr>
             <a:r>
               <a:rPr lang="en-US" sz="2400" dirty="0">
                 <a:solidFill>
@@ -6142,7 +5954,7 @@
           <a:bodyPr wrap="square" lIns="508" tIns="508" rIns="508" bIns="508" rtlCol="0" anchor="ctr"/>
           <a:lstStyle/>
           <a:p>
-            <a:pPr indent="0" marL="0">
+            <a:pPr marL="0" indent="0">
               <a:buNone/>
             </a:pPr>
             <a:r>
@@ -6156,9 +5968,6 @@
               </a:rPr>
               <a:t>M1  </a:t>
             </a:r>
-            <a:pPr indent="0" marL="0">
-              <a:buNone/>
-            </a:pPr>
             <a:r>
               <a:rPr lang="en-US" sz="2400" dirty="0">
                 <a:solidFill>
@@ -6195,7 +6004,7 @@
           <a:bodyPr wrap="square" lIns="508" tIns="508" rIns="508" bIns="508" rtlCol="0" anchor="ctr"/>
           <a:lstStyle/>
           <a:p>
-            <a:pPr algn="ctr" indent="0" marL="0">
+            <a:pPr marL="0" indent="0" algn="ctr">
               <a:buNone/>
             </a:pPr>
             <a:r>
@@ -6234,7 +6043,7 @@
           <a:bodyPr wrap="square" lIns="508" tIns="508" rIns="508" bIns="508" rtlCol="0" anchor="t"/>
           <a:lstStyle/>
           <a:p>
-            <a:pPr indent="0" marL="0">
+            <a:pPr marL="0" indent="0">
               <a:buNone/>
             </a:pPr>
             <a:r>
@@ -6272,7 +6081,7 @@
           </a:prstGeom>
           <a:extLst>
             <a:ext uri="{C572A759-6A51-4108-AA02-DFA0A04FC94B}">
-              <ma14:wrappingTextBoxFlag xmlns:ma14="http://schemas.microsoft.com/office/mac/drawingml/2011/main" val="0"/>
+              <ma14:wrappingTextBoxFlag xmlns:ma14="http://schemas.microsoft.com/office/mac/drawingml/2011/main" xmlns="" val="0"/>
             </a:ext>
           </a:extLst>
         </p:spPr>
@@ -6293,7 +6102,7 @@
           <a:p>
             <a:pPr algn="r"/>
             <a:fld id="{F7021451-1387-4CA6-816F-3879F97B5CBC}" type="slidenum">
-              <a:rPr b="0" lang="en-US"/>
+              <a:rPr lang="en-US" b="0"/>
               <a:t>2</a:t>
             </a:fld>
             <a:endParaRPr lang="en-US"/>
@@ -6328,9 +6137,11 @@
       <p:sp>
         <p:nvSpPr>
           <p:cNvPr id="2" name="Text 0"/>
-          <p:cNvSpPr/>
+          <p:cNvSpPr>
+            <a:spLocks noGrp="1"/>
+          </p:cNvSpPr>
           <p:nvPr>
-            <p:ph idx="100" type="title" hasCustomPrompt="1"/>
+            <p:ph type="title" idx="100" hasCustomPrompt="1"/>
           </p:nvPr>
         </p:nvSpPr>
         <p:spPr>
@@ -6348,7 +6159,7 @@
           <a:bodyPr wrap="square" lIns="0" tIns="0" rIns="0" bIns="0" rtlCol="0" anchor="ctr"/>
           <a:lstStyle/>
           <a:p>
-            <a:pPr algn="l" indent="0" marL="0">
+            <a:pPr marL="0" indent="0" algn="l">
               <a:buNone/>
             </a:pPr>
             <a:r>
@@ -6439,7 +6250,7 @@
           <a:bodyPr wrap="square" lIns="0" tIns="0" rIns="0" bIns="0" rtlCol="0" anchor="ctr"/>
           <a:lstStyle/>
           <a:p>
-            <a:pPr indent="0" marL="0">
+            <a:pPr marL="0" indent="0">
               <a:buNone/>
             </a:pPr>
             <a:r>
@@ -6483,7 +6294,7 @@
             <a:prstDash val="solid"/>
           </a:ln>
           <a:effectLst>
-            <a:outerShdw sx="100000" sy="100000" kx="0" ky="0" algn="bl" rotWithShape="0" blurRad="101600" dist="25400" dir="5400000">
+            <a:outerShdw blurRad="101600" dist="25400" dir="5400000" algn="bl" rotWithShape="0">
               <a:srgbClr val="7FB8D6">
                 <a:alpha val="25000"/>
               </a:srgbClr>
@@ -6493,14 +6304,14 @@
       </p:sp>
       <p:pic>
         <p:nvPicPr>
-          <p:cNvPr id="7" name="pres_mapa.png" descr="Mapa de las 13 estaciones con altitud y porcentaje de días con superación">    </p:cNvPr>
+          <p:cNvPr id="7" name="pres_mapa.png" descr="Mapa de las 13 estaciones con altitud y porcentaje de días con superación"/>
           <p:cNvPicPr>
             <a:picLocks noChangeAspect="1"/>
           </p:cNvPicPr>
           <p:nvPr/>
         </p:nvPicPr>
         <p:blipFill>
-          <a:blip r:embed="rId1"/>
+          <a:blip r:embed="rId3"/>
           <a:stretch>
             <a:fillRect/>
           </a:stretch>
@@ -6536,7 +6347,7 @@
           <a:bodyPr wrap="square" lIns="508" tIns="508" rIns="508" bIns="508" rtlCol="0" anchor="t"/>
           <a:lstStyle/>
           <a:p>
-            <a:pPr indent="0" marL="0">
+            <a:pPr marL="0" indent="0">
               <a:buNone/>
             </a:pPr>
             <a:r>
@@ -6580,7 +6391,7 @@
             <a:prstDash val="solid"/>
           </a:ln>
           <a:effectLst>
-            <a:outerShdw sx="100000" sy="100000" kx="0" ky="0" algn="bl" rotWithShape="0" blurRad="101600" dist="25400" dir="5400000">
+            <a:outerShdw blurRad="101600" dist="25400" dir="5400000" algn="bl" rotWithShape="0">
               <a:srgbClr val="7FB8D6">
                 <a:alpha val="25000"/>
               </a:srgbClr>
@@ -6609,7 +6420,7 @@
           <a:bodyPr wrap="square" lIns="508" tIns="508" rIns="508" bIns="508" rtlCol="0" anchor="t"/>
           <a:lstStyle/>
           <a:p>
-            <a:pPr indent="0" marL="0">
+            <a:pPr marL="0" indent="0">
               <a:buNone/>
             </a:pPr>
             <a:r>
@@ -6648,7 +6459,7 @@
           <a:bodyPr wrap="square" lIns="508" tIns="508" rIns="508" bIns="508" rtlCol="0" anchor="t"/>
           <a:lstStyle/>
           <a:p>
-            <a:pPr indent="0" marL="0">
+            <a:pPr marL="0" indent="0">
               <a:buNone/>
             </a:pPr>
             <a:r>
@@ -6692,7 +6503,7 @@
             <a:prstDash val="solid"/>
           </a:ln>
           <a:effectLst>
-            <a:outerShdw sx="100000" sy="100000" kx="0" ky="0" algn="bl" rotWithShape="0" blurRad="101600" dist="25400" dir="5400000">
+            <a:outerShdw blurRad="101600" dist="25400" dir="5400000" algn="bl" rotWithShape="0">
               <a:srgbClr val="7FB8D6">
                 <a:alpha val="25000"/>
               </a:srgbClr>
@@ -6721,7 +6532,7 @@
           <a:bodyPr wrap="square" lIns="508" tIns="508" rIns="508" bIns="508" rtlCol="0" anchor="t"/>
           <a:lstStyle/>
           <a:p>
-            <a:pPr indent="0" marL="0">
+            <a:pPr marL="0" indent="0">
               <a:buNone/>
             </a:pPr>
             <a:r>
@@ -6760,7 +6571,7 @@
           <a:bodyPr wrap="square" lIns="508" tIns="508" rIns="508" bIns="508" rtlCol="0" anchor="t"/>
           <a:lstStyle/>
           <a:p>
-            <a:pPr indent="0" marL="0">
+            <a:pPr marL="0" indent="0">
               <a:buNone/>
             </a:pPr>
             <a:r>
@@ -6804,7 +6615,7 @@
             <a:prstDash val="solid"/>
           </a:ln>
           <a:effectLst>
-            <a:outerShdw sx="100000" sy="100000" kx="0" ky="0" algn="bl" rotWithShape="0" blurRad="101600" dist="25400" dir="5400000">
+            <a:outerShdw blurRad="101600" dist="25400" dir="5400000" algn="bl" rotWithShape="0">
               <a:srgbClr val="7FB8D6">
                 <a:alpha val="25000"/>
               </a:srgbClr>
@@ -6833,7 +6644,7 @@
           <a:bodyPr wrap="square" lIns="508" tIns="508" rIns="508" bIns="508" rtlCol="0" anchor="t"/>
           <a:lstStyle/>
           <a:p>
-            <a:pPr indent="0" marL="0">
+            <a:pPr marL="0" indent="0">
               <a:buNone/>
             </a:pPr>
             <a:r>
@@ -6872,7 +6683,7 @@
           <a:bodyPr wrap="square" lIns="508" tIns="508" rIns="508" bIns="508" rtlCol="0" anchor="t"/>
           <a:lstStyle/>
           <a:p>
-            <a:pPr indent="0" marL="0">
+            <a:pPr marL="0" indent="0">
               <a:buNone/>
             </a:pPr>
             <a:r>
@@ -6910,7 +6721,7 @@
           </a:prstGeom>
           <a:extLst>
             <a:ext uri="{C572A759-6A51-4108-AA02-DFA0A04FC94B}">
-              <ma14:wrappingTextBoxFlag xmlns:ma14="http://schemas.microsoft.com/office/mac/drawingml/2011/main" val="0"/>
+              <ma14:wrappingTextBoxFlag xmlns:ma14="http://schemas.microsoft.com/office/mac/drawingml/2011/main" xmlns="" val="0"/>
             </a:ext>
           </a:extLst>
         </p:spPr>
@@ -6931,7 +6742,7 @@
           <a:p>
             <a:pPr algn="r"/>
             <a:fld id="{F7021451-1387-4CA6-816F-3879F97B5CBC}" type="slidenum">
-              <a:rPr b="0" lang="en-US"/>
+              <a:rPr lang="en-US" b="0"/>
               <a:t>3</a:t>
             </a:fld>
             <a:endParaRPr lang="en-US"/>
@@ -6966,9 +6777,11 @@
       <p:sp>
         <p:nvSpPr>
           <p:cNvPr id="2" name="Text 0"/>
-          <p:cNvSpPr/>
+          <p:cNvSpPr>
+            <a:spLocks noGrp="1"/>
+          </p:cNvSpPr>
           <p:nvPr>
-            <p:ph idx="100" type="title" hasCustomPrompt="1"/>
+            <p:ph type="title" idx="100" hasCustomPrompt="1"/>
           </p:nvPr>
         </p:nvSpPr>
         <p:spPr>
@@ -6986,7 +6799,7 @@
           <a:bodyPr wrap="square" lIns="0" tIns="0" rIns="0" bIns="0" rtlCol="0" anchor="ctr"/>
           <a:lstStyle/>
           <a:p>
-            <a:pPr algn="l" indent="0" marL="0">
+            <a:pPr marL="0" indent="0" algn="l">
               <a:buNone/>
             </a:pPr>
             <a:r>
@@ -7077,7 +6890,7 @@
           <a:bodyPr wrap="square" lIns="0" tIns="0" rIns="0" bIns="0" rtlCol="0" anchor="ctr"/>
           <a:lstStyle/>
           <a:p>
-            <a:pPr indent="0" marL="0">
+            <a:pPr marL="0" indent="0">
               <a:buNone/>
             </a:pPr>
             <a:r>
@@ -7121,7 +6934,7 @@
             <a:prstDash val="solid"/>
           </a:ln>
           <a:effectLst>
-            <a:outerShdw sx="100000" sy="100000" kx="0" ky="0" algn="bl" rotWithShape="0" blurRad="101600" dist="25400" dir="5400000">
+            <a:outerShdw blurRad="101600" dist="25400" dir="5400000" algn="bl" rotWithShape="0">
               <a:srgbClr val="7FB8D6">
                 <a:alpha val="25000"/>
               </a:srgbClr>
@@ -7150,7 +6963,7 @@
           <a:bodyPr wrap="square" lIns="0" tIns="0" rIns="0" bIns="0" rtlCol="0" anchor="ctr"/>
           <a:lstStyle/>
           <a:p>
-            <a:pPr indent="0" marL="0">
+            <a:pPr marL="0" indent="0">
               <a:buNone/>
             </a:pPr>
             <a:r>
@@ -7189,7 +7002,7 @@
           <a:bodyPr wrap="square" lIns="0" tIns="0" rIns="0" bIns="0" rtlCol="0" anchor="ctr"/>
           <a:lstStyle/>
           <a:p>
-            <a:pPr indent="0" marL="0">
+            <a:pPr marL="0" indent="0">
               <a:buNone/>
             </a:pPr>
             <a:r>
@@ -7233,7 +7046,7 @@
             <a:prstDash val="solid"/>
           </a:ln>
           <a:effectLst>
-            <a:outerShdw sx="100000" sy="100000" kx="0" ky="0" algn="bl" rotWithShape="0" blurRad="101600" dist="25400" dir="5400000">
+            <a:outerShdw blurRad="101600" dist="25400" dir="5400000" algn="bl" rotWithShape="0">
               <a:srgbClr val="7FB8D6">
                 <a:alpha val="25000"/>
               </a:srgbClr>
@@ -7262,7 +7075,7 @@
           <a:bodyPr wrap="square" lIns="0" tIns="0" rIns="0" bIns="0" rtlCol="0" anchor="ctr"/>
           <a:lstStyle/>
           <a:p>
-            <a:pPr indent="0" marL="0">
+            <a:pPr marL="0" indent="0">
               <a:buNone/>
             </a:pPr>
             <a:r>
@@ -7301,7 +7114,7 @@
           <a:bodyPr wrap="square" lIns="0" tIns="0" rIns="0" bIns="0" rtlCol="0" anchor="ctr"/>
           <a:lstStyle/>
           <a:p>
-            <a:pPr indent="0" marL="0">
+            <a:pPr marL="0" indent="0">
               <a:buNone/>
             </a:pPr>
             <a:r>
@@ -7345,7 +7158,7 @@
             <a:prstDash val="solid"/>
           </a:ln>
           <a:effectLst>
-            <a:outerShdw sx="100000" sy="100000" kx="0" ky="0" algn="bl" rotWithShape="0" blurRad="101600" dist="25400" dir="5400000">
+            <a:outerShdw blurRad="101600" dist="25400" dir="5400000" algn="bl" rotWithShape="0">
               <a:srgbClr val="7FB8D6">
                 <a:alpha val="25000"/>
               </a:srgbClr>
@@ -7374,7 +7187,7 @@
           <a:bodyPr wrap="square" lIns="0" tIns="0" rIns="0" bIns="0" rtlCol="0" anchor="ctr"/>
           <a:lstStyle/>
           <a:p>
-            <a:pPr indent="0" marL="0">
+            <a:pPr marL="0" indent="0">
               <a:buNone/>
             </a:pPr>
             <a:r>
@@ -7413,7 +7226,7 @@
           <a:bodyPr wrap="square" lIns="0" tIns="0" rIns="0" bIns="0" rtlCol="0" anchor="ctr"/>
           <a:lstStyle/>
           <a:p>
-            <a:pPr indent="0" marL="0">
+            <a:pPr marL="0" indent="0">
               <a:buNone/>
             </a:pPr>
             <a:r>
@@ -7457,7 +7270,7 @@
             <a:prstDash val="solid"/>
           </a:ln>
           <a:effectLst>
-            <a:outerShdw sx="100000" sy="100000" kx="0" ky="0" algn="bl" rotWithShape="0" blurRad="101600" dist="25400" dir="5400000">
+            <a:outerShdw blurRad="101600" dist="25400" dir="5400000" algn="bl" rotWithShape="0">
               <a:srgbClr val="7FB8D6">
                 <a:alpha val="25000"/>
               </a:srgbClr>
@@ -7486,7 +7299,7 @@
           <a:bodyPr wrap="square" lIns="508" tIns="508" rIns="508" bIns="508" rtlCol="0" anchor="t"/>
           <a:lstStyle/>
           <a:p>
-            <a:pPr indent="0" marL="0">
+            <a:pPr marL="0" indent="0">
               <a:buNone/>
             </a:pPr>
             <a:r>
@@ -7506,14 +7319,14 @@
       </p:sp>
       <p:pic>
         <p:nvPicPr>
-          <p:cNvPr id="17" name="pres_superacion_temporada.png" descr="Porcentaje de días-estación con PM2.5 mayor a 25 por temporada">    </p:cNvPr>
+          <p:cNvPr id="17" name="pres_superacion_temporada.png" descr="Porcentaje de días-estación con PM2.5 mayor a 25 por temporada"/>
           <p:cNvPicPr>
             <a:picLocks noChangeAspect="1"/>
           </p:cNvPicPr>
           <p:nvPr/>
         </p:nvPicPr>
         <p:blipFill>
-          <a:blip r:embed="rId1"/>
+          <a:blip r:embed="rId3"/>
           <a:stretch>
             <a:fillRect/>
           </a:stretch>
@@ -7554,7 +7367,7 @@
             <a:prstDash val="solid"/>
           </a:ln>
           <a:effectLst>
-            <a:outerShdw sx="100000" sy="100000" kx="0" ky="0" algn="bl" rotWithShape="0" blurRad="101600" dist="25400" dir="5400000">
+            <a:outerShdw blurRad="101600" dist="25400" dir="5400000" algn="bl" rotWithShape="0">
               <a:srgbClr val="7FB8D6">
                 <a:alpha val="25000"/>
               </a:srgbClr>
@@ -7583,7 +7396,7 @@
           <a:bodyPr wrap="square" lIns="508" tIns="508" rIns="508" bIns="508" rtlCol="0" anchor="t"/>
           <a:lstStyle/>
           <a:p>
-            <a:pPr indent="0" marL="0">
+            <a:pPr marL="0" indent="0">
               <a:buNone/>
             </a:pPr>
             <a:r>
@@ -7603,14 +7416,14 @@
       </p:sp>
       <p:pic>
         <p:nvPicPr>
-          <p:cNvPr id="20" name="pres_temperatura_simpson.png" descr="Diferencia de temperatura entre días con y sin superación, global y por temporada">    </p:cNvPr>
+          <p:cNvPr id="20" name="pres_temperatura_simpson.png" descr="Diferencia de temperatura entre días con y sin superación, global y por temporada"/>
           <p:cNvPicPr>
             <a:picLocks noChangeAspect="1"/>
           </p:cNvPicPr>
           <p:nvPr/>
         </p:nvPicPr>
         <p:blipFill>
-          <a:blip r:embed="rId2"/>
+          <a:blip r:embed="rId4"/>
           <a:stretch>
             <a:fillRect/>
           </a:stretch>
@@ -7645,7 +7458,7 @@
           </a:prstGeom>
           <a:extLst>
             <a:ext uri="{C572A759-6A51-4108-AA02-DFA0A04FC94B}">
-              <ma14:wrappingTextBoxFlag xmlns:ma14="http://schemas.microsoft.com/office/mac/drawingml/2011/main" val="0"/>
+              <ma14:wrappingTextBoxFlag xmlns:ma14="http://schemas.microsoft.com/office/mac/drawingml/2011/main" xmlns="" val="0"/>
             </a:ext>
           </a:extLst>
         </p:spPr>
@@ -7666,7 +7479,7 @@
           <a:p>
             <a:pPr algn="r"/>
             <a:fld id="{F7021451-1387-4CA6-816F-3879F97B5CBC}" type="slidenum">
-              <a:rPr b="0" lang="en-US"/>
+              <a:rPr lang="en-US" b="0"/>
               <a:t>4</a:t>
             </a:fld>
             <a:endParaRPr lang="en-US"/>
@@ -7701,9 +7514,11 @@
       <p:sp>
         <p:nvSpPr>
           <p:cNvPr id="2" name="Text 0"/>
-          <p:cNvSpPr/>
+          <p:cNvSpPr>
+            <a:spLocks noGrp="1"/>
+          </p:cNvSpPr>
           <p:nvPr>
-            <p:ph idx="100" type="title" hasCustomPrompt="1"/>
+            <p:ph type="title" idx="100" hasCustomPrompt="1"/>
           </p:nvPr>
         </p:nvSpPr>
         <p:spPr>
@@ -7721,7 +7536,7 @@
           <a:bodyPr wrap="square" lIns="0" tIns="0" rIns="0" bIns="0" rtlCol="0" anchor="ctr"/>
           <a:lstStyle/>
           <a:p>
-            <a:pPr algn="l" indent="0" marL="0">
+            <a:pPr marL="0" indent="0" algn="l">
               <a:buNone/>
             </a:pPr>
             <a:r>
@@ -7812,7 +7627,7 @@
           <a:bodyPr wrap="square" lIns="0" tIns="0" rIns="0" bIns="0" rtlCol="0" anchor="ctr"/>
           <a:lstStyle/>
           <a:p>
-            <a:pPr indent="0" marL="0">
+            <a:pPr marL="0" indent="0">
               <a:buNone/>
             </a:pPr>
             <a:r>
@@ -7856,7 +7671,7 @@
             <a:prstDash val="solid"/>
           </a:ln>
           <a:effectLst>
-            <a:outerShdw sx="100000" sy="100000" kx="0" ky="0" algn="bl" rotWithShape="0" blurRad="101600" dist="25400" dir="5400000">
+            <a:outerShdw blurRad="101600" dist="25400" dir="5400000" algn="bl" rotWithShape="0">
               <a:srgbClr val="7FB8D6">
                 <a:alpha val="25000"/>
               </a:srgbClr>
@@ -7885,7 +7700,7 @@
           <a:bodyPr wrap="square" lIns="508" tIns="508" rIns="508" bIns="508" rtlCol="0" anchor="ctr"/>
           <a:lstStyle/>
           <a:p>
-            <a:pPr indent="0" marL="0">
+            <a:pPr marL="0" indent="0">
               <a:buNone/>
             </a:pPr>
             <a:r>
@@ -7899,9 +7714,6 @@
               </a:rPr>
               <a:t>Faltaba el 12.3 % de los datos</a:t>
             </a:r>
-            <a:pPr indent="0" marL="0">
-              <a:buNone/>
-            </a:pPr>
             <a:r>
               <a:rPr lang="en-US" sz="2000" dirty="0">
                 <a:solidFill>
@@ -7943,7 +7755,7 @@
             <a:prstDash val="solid"/>
           </a:ln>
           <a:effectLst>
-            <a:outerShdw sx="100000" sy="100000" kx="0" ky="0" algn="bl" rotWithShape="0" blurRad="101600" dist="25400" dir="5400000">
+            <a:outerShdw blurRad="101600" dist="25400" dir="5400000" algn="bl" rotWithShape="0">
               <a:srgbClr val="7FB8D6">
                 <a:alpha val="25000"/>
               </a:srgbClr>
@@ -7997,7 +7809,7 @@
           <a:bodyPr wrap="square" lIns="0" tIns="0" rIns="0" bIns="0" rtlCol="0" anchor="ctr"/>
           <a:lstStyle/>
           <a:p>
-            <a:pPr algn="ctr" indent="0" marL="0">
+            <a:pPr marL="0" indent="0" algn="ctr">
               <a:buNone/>
             </a:pPr>
             <a:r>
@@ -8036,7 +7848,7 @@
           <a:bodyPr wrap="square" lIns="0" tIns="0" rIns="0" bIns="0" rtlCol="0" anchor="ctr"/>
           <a:lstStyle/>
           <a:p>
-            <a:pPr indent="0" marL="0">
+            <a:pPr marL="0" indent="0">
               <a:buNone/>
             </a:pPr>
             <a:r>
@@ -8075,7 +7887,7 @@
           <a:bodyPr wrap="square" lIns="508" tIns="508" rIns="508" bIns="508" rtlCol="0" anchor="ctr"/>
           <a:lstStyle/>
           <a:p>
-            <a:pPr indent="0" marL="0">
+            <a:pPr marL="0" indent="0">
               <a:buNone/>
             </a:pPr>
             <a:r>
@@ -8114,7 +7926,7 @@
           <a:bodyPr wrap="square" lIns="508" tIns="508" rIns="508" bIns="508" rtlCol="0" anchor="t"/>
           <a:lstStyle/>
           <a:p>
-            <a:pPr indent="0" marL="0">
+            <a:pPr marL="0" indent="0">
               <a:buNone/>
             </a:pPr>
             <a:r>
@@ -8183,7 +7995,7 @@
             <a:prstDash val="solid"/>
           </a:ln>
           <a:effectLst>
-            <a:outerShdw sx="100000" sy="100000" kx="0" ky="0" algn="bl" rotWithShape="0" blurRad="101600" dist="25400" dir="5400000">
+            <a:outerShdw blurRad="101600" dist="25400" dir="5400000" algn="bl" rotWithShape="0">
               <a:srgbClr val="7FB8D6">
                 <a:alpha val="25000"/>
               </a:srgbClr>
@@ -8237,7 +8049,7 @@
           <a:bodyPr wrap="square" lIns="0" tIns="0" rIns="0" bIns="0" rtlCol="0" anchor="ctr"/>
           <a:lstStyle/>
           <a:p>
-            <a:pPr algn="ctr" indent="0" marL="0">
+            <a:pPr marL="0" indent="0" algn="ctr">
               <a:buNone/>
             </a:pPr>
             <a:r>
@@ -8276,7 +8088,7 @@
           <a:bodyPr wrap="square" lIns="0" tIns="0" rIns="0" bIns="0" rtlCol="0" anchor="ctr"/>
           <a:lstStyle/>
           <a:p>
-            <a:pPr indent="0" marL="0">
+            <a:pPr marL="0" indent="0">
               <a:buNone/>
             </a:pPr>
             <a:r>
@@ -8315,7 +8127,7 @@
           <a:bodyPr wrap="square" lIns="508" tIns="508" rIns="508" bIns="508" rtlCol="0" anchor="ctr"/>
           <a:lstStyle/>
           <a:p>
-            <a:pPr indent="0" marL="0">
+            <a:pPr marL="0" indent="0">
               <a:buNone/>
             </a:pPr>
             <a:r>
@@ -8354,7 +8166,7 @@
           <a:bodyPr wrap="square" lIns="508" tIns="508" rIns="508" bIns="508" rtlCol="0" anchor="t"/>
           <a:lstStyle/>
           <a:p>
-            <a:pPr indent="0" marL="0">
+            <a:pPr marL="0" indent="0">
               <a:buNone/>
             </a:pPr>
             <a:r>
@@ -8423,7 +8235,7 @@
             <a:prstDash val="solid"/>
           </a:ln>
           <a:effectLst>
-            <a:outerShdw sx="100000" sy="100000" kx="0" ky="0" algn="bl" rotWithShape="0" blurRad="101600" dist="25400" dir="5400000">
+            <a:outerShdw blurRad="101600" dist="25400" dir="5400000" algn="bl" rotWithShape="0">
               <a:srgbClr val="7FB8D6">
                 <a:alpha val="25000"/>
               </a:srgbClr>
@@ -8477,7 +8289,7 @@
           <a:bodyPr wrap="square" lIns="0" tIns="0" rIns="0" bIns="0" rtlCol="0" anchor="ctr"/>
           <a:lstStyle/>
           <a:p>
-            <a:pPr algn="ctr" indent="0" marL="0">
+            <a:pPr marL="0" indent="0" algn="ctr">
               <a:buNone/>
             </a:pPr>
             <a:r>
@@ -8516,7 +8328,7 @@
           <a:bodyPr wrap="square" lIns="0" tIns="0" rIns="0" bIns="0" rtlCol="0" anchor="ctr"/>
           <a:lstStyle/>
           <a:p>
-            <a:pPr indent="0" marL="0">
+            <a:pPr marL="0" indent="0">
               <a:buNone/>
             </a:pPr>
             <a:r>
@@ -8555,7 +8367,7 @@
           <a:bodyPr wrap="square" lIns="508" tIns="508" rIns="508" bIns="508" rtlCol="0" anchor="ctr"/>
           <a:lstStyle/>
           <a:p>
-            <a:pPr indent="0" marL="0">
+            <a:pPr marL="0" indent="0">
               <a:buNone/>
             </a:pPr>
             <a:r>
@@ -8594,7 +8406,7 @@
           <a:bodyPr wrap="square" lIns="508" tIns="508" rIns="508" bIns="508" rtlCol="0" anchor="t"/>
           <a:lstStyle/>
           <a:p>
-            <a:pPr indent="0" marL="0">
+            <a:pPr marL="0" indent="0">
               <a:buNone/>
             </a:pPr>
             <a:r>
@@ -8638,7 +8450,7 @@
             <a:prstDash val="solid"/>
           </a:ln>
           <a:effectLst>
-            <a:outerShdw sx="100000" sy="100000" kx="0" ky="0" algn="bl" rotWithShape="0" blurRad="101600" dist="25400" dir="5400000">
+            <a:outerShdw blurRad="101600" dist="25400" dir="5400000" algn="bl" rotWithShape="0">
               <a:srgbClr val="7FB8D6">
                 <a:alpha val="25000"/>
               </a:srgbClr>
@@ -8667,7 +8479,7 @@
           <a:bodyPr wrap="square" lIns="508" tIns="508" rIns="508" bIns="508" rtlCol="0" anchor="ctr"/>
           <a:lstStyle/>
           <a:p>
-            <a:pPr indent="0" marL="0">
+            <a:pPr marL="0" indent="0">
               <a:buNone/>
             </a:pPr>
             <a:r>
@@ -8681,9 +8493,6 @@
               </a:rPr>
               <a:t>Resultado: </a:t>
             </a:r>
-            <a:pPr indent="0" marL="0">
-              <a:buNone/>
-            </a:pPr>
             <a:r>
               <a:rPr lang="en-US" sz="2000" dirty="0">
                 <a:solidFill>
@@ -8695,9 +8504,6 @@
               </a:rPr>
               <a:t>+2 438 días frente a la etapa anterior; García (NO2) pasa de </a:t>
             </a:r>
-            <a:pPr indent="0" marL="0">
-              <a:buNone/>
-            </a:pPr>
             <a:r>
               <a:rPr lang="en-US" sz="2000" b="1" dirty="0">
                 <a:solidFill>
@@ -8734,7 +8540,7 @@
           <a:bodyPr wrap="square" lIns="508" tIns="508" rIns="508" bIns="508" rtlCol="0" anchor="t"/>
           <a:lstStyle/>
           <a:p>
-            <a:pPr indent="0" marL="0">
+            <a:pPr marL="0" indent="0">
               <a:buNone/>
             </a:pPr>
             <a:r>
@@ -8746,7 +8552,7 @@
                 <a:ea typeface="Calibri" pitchFamily="34" charset="-122"/>
                 <a:cs typeface="Calibri" pitchFamily="34" charset="-120"/>
               </a:rPr>
-              <a:t>MIMA-v1 no se comparó: no tuvimos acceso al código e imputa la respuesta.</a:t>
+              <a:t>MIMA-v1 no se comparó: no tuvimos acceso a su dataset e imputa la respuesta.</a:t>
             </a:r>
             <a:endParaRPr lang="en-US" sz="1600" dirty="0"/>
           </a:p>
@@ -8754,7 +8560,7 @@
       </p:sp>
       <p:sp>
         <p:nvSpPr>
-          <p:cNvPr id="25" name="Slide Number Placeholder 0"/>
+          <p:cNvPr id="31" name="Slide Number Placeholder 0"/>
           <p:cNvSpPr>
             <a:spLocks noGrp="1"/>
           </p:cNvSpPr>
@@ -8772,7 +8578,7 @@
           </a:prstGeom>
           <a:extLst>
             <a:ext uri="{C572A759-6A51-4108-AA02-DFA0A04FC94B}">
-              <ma14:wrappingTextBoxFlag xmlns:ma14="http://schemas.microsoft.com/office/mac/drawingml/2011/main" val="0"/>
+              <ma14:wrappingTextBoxFlag xmlns:ma14="http://schemas.microsoft.com/office/mac/drawingml/2011/main" xmlns="" val="0"/>
             </a:ext>
           </a:extLst>
         </p:spPr>
@@ -8793,7 +8599,7 @@
           <a:p>
             <a:pPr algn="r"/>
             <a:fld id="{F7021451-1387-4CA6-816F-3879F97B5CBC}" type="slidenum">
-              <a:rPr b="0" lang="en-US"/>
+              <a:rPr lang="en-US" b="0"/>
               <a:t>5</a:t>
             </a:fld>
             <a:endParaRPr lang="en-US"/>
@@ -8828,9 +8634,11 @@
       <p:sp>
         <p:nvSpPr>
           <p:cNvPr id="2" name="Text 0"/>
-          <p:cNvSpPr/>
+          <p:cNvSpPr>
+            <a:spLocks noGrp="1"/>
+          </p:cNvSpPr>
           <p:nvPr>
-            <p:ph idx="100" type="title" hasCustomPrompt="1"/>
+            <p:ph type="title" idx="100" hasCustomPrompt="1"/>
           </p:nvPr>
         </p:nvSpPr>
         <p:spPr>
@@ -8848,7 +8656,7 @@
           <a:bodyPr wrap="square" lIns="0" tIns="0" rIns="0" bIns="0" rtlCol="0" anchor="ctr"/>
           <a:lstStyle/>
           <a:p>
-            <a:pPr algn="l" indent="0" marL="0">
+            <a:pPr marL="0" indent="0" algn="l">
               <a:buNone/>
             </a:pPr>
             <a:r>
@@ -8939,7 +8747,7 @@
           <a:bodyPr wrap="square" lIns="0" tIns="0" rIns="0" bIns="0" rtlCol="0" anchor="ctr"/>
           <a:lstStyle/>
           <a:p>
-            <a:pPr indent="0" marL="0">
+            <a:pPr marL="0" indent="0">
               <a:buNone/>
             </a:pPr>
             <a:r>
@@ -8983,7 +8791,7 @@
             <a:prstDash val="solid"/>
           </a:ln>
           <a:effectLst>
-            <a:outerShdw sx="100000" sy="100000" kx="0" ky="0" algn="bl" rotWithShape="0" blurRad="101600" dist="25400" dir="5400000">
+            <a:outerShdw blurRad="101600" dist="25400" dir="5400000" algn="bl" rotWithShape="0">
               <a:srgbClr val="7FB8D6">
                 <a:alpha val="25000"/>
               </a:srgbClr>
@@ -9039,7 +8847,7 @@
           <a:bodyPr wrap="square" lIns="508" tIns="508" rIns="508" bIns="508" rtlCol="0" anchor="ctr"/>
           <a:lstStyle/>
           <a:p>
-            <a:pPr algn="ctr" indent="0" marL="0">
+            <a:pPr marL="0" indent="0" algn="ctr">
               <a:buNone/>
             </a:pPr>
             <a:r>
@@ -9078,7 +8886,7 @@
           <a:bodyPr wrap="square" lIns="508" tIns="508" rIns="508" bIns="508" rtlCol="0" anchor="ctr"/>
           <a:lstStyle/>
           <a:p>
-            <a:pPr algn="ctr" indent="0" marL="0">
+            <a:pPr marL="0" indent="0" algn="ctr">
               <a:buNone/>
             </a:pPr>
             <a:r>
@@ -9117,7 +8925,7 @@
           <a:bodyPr wrap="square" lIns="508" tIns="508" rIns="508" bIns="508" rtlCol="0" anchor="ctr"/>
           <a:lstStyle/>
           <a:p>
-            <a:pPr algn="ctr" indent="0" marL="0">
+            <a:pPr marL="0" indent="0" algn="ctr">
               <a:buNone/>
             </a:pPr>
             <a:r>
@@ -9186,7 +8994,7 @@
             <a:prstDash val="solid"/>
           </a:ln>
           <a:effectLst>
-            <a:outerShdw sx="100000" sy="100000" kx="0" ky="0" algn="bl" rotWithShape="0" blurRad="101600" dist="25400" dir="5400000">
+            <a:outerShdw blurRad="101600" dist="25400" dir="5400000" algn="bl" rotWithShape="0">
               <a:srgbClr val="7FB8D6">
                 <a:alpha val="25000"/>
               </a:srgbClr>
@@ -9242,7 +9050,7 @@
           <a:bodyPr wrap="square" lIns="508" tIns="508" rIns="508" bIns="508" rtlCol="0" anchor="ctr"/>
           <a:lstStyle/>
           <a:p>
-            <a:pPr algn="ctr" indent="0" marL="0">
+            <a:pPr marL="0" indent="0" algn="ctr">
               <a:buNone/>
             </a:pPr>
             <a:r>
@@ -9281,7 +9089,7 @@
           <a:bodyPr wrap="square" lIns="508" tIns="508" rIns="508" bIns="508" rtlCol="0" anchor="ctr"/>
           <a:lstStyle/>
           <a:p>
-            <a:pPr algn="ctr" indent="0" marL="0">
+            <a:pPr marL="0" indent="0" algn="ctr">
               <a:buNone/>
             </a:pPr>
             <a:r>
@@ -9320,7 +9128,7 @@
           <a:bodyPr wrap="square" lIns="508" tIns="508" rIns="508" bIns="508" rtlCol="0" anchor="ctr"/>
           <a:lstStyle/>
           <a:p>
-            <a:pPr algn="ctr" indent="0" marL="0">
+            <a:pPr marL="0" indent="0" algn="ctr">
               <a:buNone/>
             </a:pPr>
             <a:r>
@@ -9389,7 +9197,7 @@
             <a:prstDash val="solid"/>
           </a:ln>
           <a:effectLst>
-            <a:outerShdw sx="100000" sy="100000" kx="0" ky="0" algn="bl" rotWithShape="0" blurRad="101600" dist="25400" dir="5400000">
+            <a:outerShdw blurRad="101600" dist="25400" dir="5400000" algn="bl" rotWithShape="0">
               <a:srgbClr val="7FB8D6">
                 <a:alpha val="25000"/>
               </a:srgbClr>
@@ -9445,7 +9253,7 @@
           <a:bodyPr wrap="square" lIns="508" tIns="508" rIns="508" bIns="508" rtlCol="0" anchor="ctr"/>
           <a:lstStyle/>
           <a:p>
-            <a:pPr algn="ctr" indent="0" marL="0">
+            <a:pPr marL="0" indent="0" algn="ctr">
               <a:buNone/>
             </a:pPr>
             <a:r>
@@ -9484,7 +9292,7 @@
           <a:bodyPr wrap="square" lIns="508" tIns="508" rIns="508" bIns="508" rtlCol="0" anchor="ctr"/>
           <a:lstStyle/>
           <a:p>
-            <a:pPr algn="ctr" indent="0" marL="0">
+            <a:pPr marL="0" indent="0" algn="ctr">
               <a:buNone/>
             </a:pPr>
             <a:r>
@@ -9523,7 +9331,7 @@
           <a:bodyPr wrap="square" lIns="508" tIns="508" rIns="508" bIns="508" rtlCol="0" anchor="ctr"/>
           <a:lstStyle/>
           <a:p>
-            <a:pPr algn="ctr" indent="0" marL="0">
+            <a:pPr marL="0" indent="0" algn="ctr">
               <a:buNone/>
             </a:pPr>
             <a:r>
@@ -9592,7 +9400,7 @@
             <a:prstDash val="solid"/>
           </a:ln>
           <a:effectLst>
-            <a:outerShdw sx="100000" sy="100000" kx="0" ky="0" algn="bl" rotWithShape="0" blurRad="101600" dist="25400" dir="5400000">
+            <a:outerShdw blurRad="101600" dist="25400" dir="5400000" algn="bl" rotWithShape="0">
               <a:srgbClr val="7FB8D6">
                 <a:alpha val="25000"/>
               </a:srgbClr>
@@ -9648,7 +9456,7 @@
           <a:bodyPr wrap="square" lIns="508" tIns="508" rIns="508" bIns="508" rtlCol="0" anchor="ctr"/>
           <a:lstStyle/>
           <a:p>
-            <a:pPr algn="ctr" indent="0" marL="0">
+            <a:pPr marL="0" indent="0" algn="ctr">
               <a:buNone/>
             </a:pPr>
             <a:r>
@@ -9687,7 +9495,7 @@
           <a:bodyPr wrap="square" lIns="508" tIns="508" rIns="508" bIns="508" rtlCol="0" anchor="ctr"/>
           <a:lstStyle/>
           <a:p>
-            <a:pPr algn="ctr" indent="0" marL="0">
+            <a:pPr marL="0" indent="0" algn="ctr">
               <a:buNone/>
             </a:pPr>
             <a:r>
@@ -9726,7 +9534,7 @@
           <a:bodyPr wrap="square" lIns="508" tIns="508" rIns="508" bIns="508" rtlCol="0" anchor="ctr"/>
           <a:lstStyle/>
           <a:p>
-            <a:pPr algn="ctr" indent="0" marL="0">
+            <a:pPr marL="0" indent="0" algn="ctr">
               <a:buNone/>
             </a:pPr>
             <a:r>
@@ -9770,7 +9578,7 @@
             <a:prstDash val="solid"/>
           </a:ln>
           <a:effectLst>
-            <a:outerShdw sx="100000" sy="100000" kx="0" ky="0" algn="bl" rotWithShape="0" blurRad="101600" dist="25400" dir="5400000">
+            <a:outerShdw blurRad="101600" dist="25400" dir="5400000" algn="bl" rotWithShape="0">
               <a:srgbClr val="7FB8D6">
                 <a:alpha val="25000"/>
               </a:srgbClr>
@@ -9799,7 +9607,7 @@
           <a:bodyPr wrap="square" lIns="508" tIns="508" rIns="508" bIns="508" rtlCol="0" anchor="ctr"/>
           <a:lstStyle/>
           <a:p>
-            <a:pPr indent="0" marL="0">
+            <a:pPr marL="0" indent="0">
               <a:buNone/>
             </a:pPr>
             <a:r>
@@ -9813,9 +9621,6 @@
               </a:rPr>
               <a:t>Estación y temporada entran como variables indicadoras</a:t>
             </a:r>
-            <a:pPr indent="0" marL="0">
-              <a:buNone/>
-            </a:pPr>
             <a:r>
               <a:rPr lang="en-US" sz="2000" dirty="0">
                 <a:solidFill>
@@ -9833,7 +9638,7 @@
       </p:sp>
       <p:sp>
         <p:nvSpPr>
-          <p:cNvPr id="25" name="Slide Number Placeholder 0"/>
+          <p:cNvPr id="31" name="Slide Number Placeholder 0"/>
           <p:cNvSpPr>
             <a:spLocks noGrp="1"/>
           </p:cNvSpPr>
@@ -9851,7 +9656,7 @@
           </a:prstGeom>
           <a:extLst>
             <a:ext uri="{C572A759-6A51-4108-AA02-DFA0A04FC94B}">
-              <ma14:wrappingTextBoxFlag xmlns:ma14="http://schemas.microsoft.com/office/mac/drawingml/2011/main" val="0"/>
+              <ma14:wrappingTextBoxFlag xmlns:ma14="http://schemas.microsoft.com/office/mac/drawingml/2011/main" xmlns="" val="0"/>
             </a:ext>
           </a:extLst>
         </p:spPr>
@@ -9872,7 +9677,7 @@
           <a:p>
             <a:pPr algn="r"/>
             <a:fld id="{F7021451-1387-4CA6-816F-3879F97B5CBC}" type="slidenum">
-              <a:rPr b="0" lang="en-US"/>
+              <a:rPr lang="en-US" b="0"/>
               <a:t>6</a:t>
             </a:fld>
             <a:endParaRPr lang="en-US"/>
@@ -9907,9 +9712,11 @@
       <p:sp>
         <p:nvSpPr>
           <p:cNvPr id="2" name="Text 0"/>
-          <p:cNvSpPr/>
+          <p:cNvSpPr>
+            <a:spLocks noGrp="1"/>
+          </p:cNvSpPr>
           <p:nvPr>
-            <p:ph idx="100" type="title" hasCustomPrompt="1"/>
+            <p:ph type="title" idx="100" hasCustomPrompt="1"/>
           </p:nvPr>
         </p:nvSpPr>
         <p:spPr>
@@ -9927,7 +9734,7 @@
           <a:bodyPr wrap="square" lIns="0" tIns="0" rIns="0" bIns="0" rtlCol="0" anchor="ctr"/>
           <a:lstStyle/>
           <a:p>
-            <a:pPr algn="l" indent="0" marL="0">
+            <a:pPr marL="0" indent="0" algn="l">
               <a:buNone/>
             </a:pPr>
             <a:r>
@@ -10018,7 +9825,7 @@
           <a:bodyPr wrap="square" lIns="0" tIns="0" rIns="0" bIns="0" rtlCol="0" anchor="ctr"/>
           <a:lstStyle/>
           <a:p>
-            <a:pPr indent="0" marL="0">
+            <a:pPr marL="0" indent="0">
               <a:buNone/>
             </a:pPr>
             <a:r>
@@ -10062,7 +9869,7 @@
             <a:prstDash val="solid"/>
           </a:ln>
           <a:effectLst>
-            <a:outerShdw sx="100000" sy="100000" kx="0" ky="0" algn="bl" rotWithShape="0" blurRad="101600" dist="25400" dir="5400000">
+            <a:outerShdw blurRad="101600" dist="25400" dir="5400000" algn="bl" rotWithShape="0">
               <a:srgbClr val="7FB8D6">
                 <a:alpha val="25000"/>
               </a:srgbClr>
@@ -10072,14 +9879,14 @@
       </p:sp>
       <p:pic>
         <p:nvPicPr>
-          <p:cNvPr id="7" name="pres_pca_cargas.png" descr="Cargas de los tres primeros componentes principales sobre las ocho variables meteorológicas">    </p:cNvPr>
+          <p:cNvPr id="7" name="pres_pca_cargas.png" descr="Cargas de los tres primeros componentes principales sobre las ocho variables meteorológicas"/>
           <p:cNvPicPr>
             <a:picLocks noChangeAspect="1"/>
           </p:cNvPicPr>
           <p:nvPr/>
         </p:nvPicPr>
         <p:blipFill>
-          <a:blip r:embed="rId1"/>
+          <a:blip r:embed="rId3"/>
           <a:stretch>
             <a:fillRect/>
           </a:stretch>
@@ -10120,7 +9927,7 @@
             <a:prstDash val="solid"/>
           </a:ln>
           <a:effectLst>
-            <a:outerShdw sx="100000" sy="100000" kx="0" ky="0" algn="bl" rotWithShape="0" blurRad="101600" dist="25400" dir="5400000">
+            <a:outerShdw blurRad="101600" dist="25400" dir="5400000" algn="bl" rotWithShape="0">
               <a:srgbClr val="7FB8D6">
                 <a:alpha val="25000"/>
               </a:srgbClr>
@@ -10149,7 +9956,7 @@
           <a:bodyPr wrap="square" lIns="508" tIns="508" rIns="508" bIns="508" rtlCol="0" anchor="ctr"/>
           <a:lstStyle/>
           <a:p>
-            <a:pPr indent="0" marL="0">
+            <a:pPr marL="0" indent="0">
               <a:buNone/>
             </a:pPr>
             <a:r>
@@ -10188,7 +9995,7 @@
           <a:bodyPr wrap="square" lIns="508" tIns="508" rIns="508" bIns="508" rtlCol="0" anchor="t"/>
           <a:lstStyle/>
           <a:p>
-            <a:pPr indent="0" marL="0">
+            <a:pPr marL="0" indent="0">
               <a:buNone/>
             </a:pPr>
             <a:r>
@@ -10232,7 +10039,7 @@
             <a:prstDash val="solid"/>
           </a:ln>
           <a:effectLst>
-            <a:outerShdw sx="100000" sy="100000" kx="0" ky="0" algn="bl" rotWithShape="0" blurRad="101600" dist="25400" dir="5400000">
+            <a:outerShdw blurRad="101600" dist="25400" dir="5400000" algn="bl" rotWithShape="0">
               <a:srgbClr val="7FB8D6">
                 <a:alpha val="25000"/>
               </a:srgbClr>
@@ -10261,7 +10068,7 @@
           <a:bodyPr wrap="square" lIns="508" tIns="508" rIns="508" bIns="508" rtlCol="0" anchor="t"/>
           <a:lstStyle/>
           <a:p>
-            <a:pPr indent="0" marL="0">
+            <a:pPr marL="0" indent="0">
               <a:buNone/>
             </a:pPr>
             <a:r>
@@ -10300,7 +10107,7 @@
           <a:bodyPr wrap="square" lIns="508" tIns="508" rIns="508" bIns="508" rtlCol="0" anchor="t"/>
           <a:lstStyle/>
           <a:p>
-            <a:pPr indent="0" marL="0">
+            <a:pPr marL="0" indent="0">
               <a:buNone/>
             </a:pPr>
             <a:r>
@@ -10338,7 +10145,7 @@
           </a:prstGeom>
           <a:extLst>
             <a:ext uri="{C572A759-6A51-4108-AA02-DFA0A04FC94B}">
-              <ma14:wrappingTextBoxFlag xmlns:ma14="http://schemas.microsoft.com/office/mac/drawingml/2011/main" val="0"/>
+              <ma14:wrappingTextBoxFlag xmlns:ma14="http://schemas.microsoft.com/office/mac/drawingml/2011/main" xmlns="" val="0"/>
             </a:ext>
           </a:extLst>
         </p:spPr>
@@ -10359,7 +10166,7 @@
           <a:p>
             <a:pPr algn="r"/>
             <a:fld id="{F7021451-1387-4CA6-816F-3879F97B5CBC}" type="slidenum">
-              <a:rPr b="0" lang="en-US"/>
+              <a:rPr lang="en-US" b="0"/>
               <a:t>7</a:t>
             </a:fld>
             <a:endParaRPr lang="en-US"/>
@@ -10394,9 +10201,11 @@
       <p:sp>
         <p:nvSpPr>
           <p:cNvPr id="2" name="Text 0"/>
-          <p:cNvSpPr/>
+          <p:cNvSpPr>
+            <a:spLocks noGrp="1"/>
+          </p:cNvSpPr>
           <p:nvPr>
-            <p:ph idx="100" type="title" hasCustomPrompt="1"/>
+            <p:ph type="title" idx="100" hasCustomPrompt="1"/>
           </p:nvPr>
         </p:nvSpPr>
         <p:spPr>
@@ -10414,7 +10223,7 @@
           <a:bodyPr wrap="square" lIns="0" tIns="0" rIns="0" bIns="0" rtlCol="0" anchor="ctr"/>
           <a:lstStyle/>
           <a:p>
-            <a:pPr algn="l" indent="0" marL="0">
+            <a:pPr marL="0" indent="0" algn="l">
               <a:buNone/>
             </a:pPr>
             <a:r>
@@ -10505,7 +10314,7 @@
           <a:bodyPr wrap="square" lIns="0" tIns="0" rIns="0" bIns="0" rtlCol="0" anchor="ctr"/>
           <a:lstStyle/>
           <a:p>
-            <a:pPr indent="0" marL="0">
+            <a:pPr marL="0" indent="0">
               <a:buNone/>
             </a:pPr>
             <a:r>
@@ -10549,7 +10358,7 @@
             <a:prstDash val="solid"/>
           </a:ln>
           <a:effectLst>
-            <a:outerShdw sx="100000" sy="100000" kx="0" ky="0" algn="bl" rotWithShape="0" blurRad="101600" dist="25400" dir="5400000">
+            <a:outerShdw blurRad="101600" dist="25400" dir="5400000" algn="bl" rotWithShape="0">
               <a:srgbClr val="7FB8D6">
                 <a:alpha val="25000"/>
               </a:srgbClr>
@@ -10559,14 +10368,14 @@
       </p:sp>
       <p:pic>
         <p:nvPicPr>
-          <p:cNvPr id="7" name="pres_roc.png" descr="Curvas ROC de M0 y M1 en la prueba 2024-2025">    </p:cNvPr>
+          <p:cNvPr id="7" name="pres_roc.png" descr="Curvas ROC de M0 y M1 en la prueba 2024-2025"/>
           <p:cNvPicPr>
             <a:picLocks noChangeAspect="1"/>
           </p:cNvPicPr>
           <p:nvPr/>
         </p:nvPicPr>
         <p:blipFill>
-          <a:blip r:embed="rId1"/>
+          <a:blip r:embed="rId3"/>
           <a:stretch>
             <a:fillRect/>
           </a:stretch>
@@ -10602,7 +10411,7 @@
           <a:bodyPr wrap="square" lIns="508" tIns="508" rIns="508" bIns="508" rtlCol="0" anchor="t"/>
           <a:lstStyle/>
           <a:p>
-            <a:pPr indent="0" marL="0">
+            <a:pPr marL="0" indent="0">
               <a:buNone/>
             </a:pPr>
             <a:r>
@@ -10646,7 +10455,7 @@
             <a:prstDash val="solid"/>
           </a:ln>
           <a:effectLst>
-            <a:outerShdw sx="100000" sy="100000" kx="0" ky="0" algn="bl" rotWithShape="0" blurRad="101600" dist="25400" dir="5400000">
+            <a:outerShdw blurRad="101600" dist="25400" dir="5400000" algn="bl" rotWithShape="0">
               <a:srgbClr val="7FB8D6">
                 <a:alpha val="25000"/>
               </a:srgbClr>
@@ -10675,7 +10484,7 @@
           <a:bodyPr wrap="square" lIns="508" tIns="508" rIns="508" bIns="508" rtlCol="0" anchor="t"/>
           <a:lstStyle/>
           <a:p>
-            <a:pPr indent="0" marL="0">
+            <a:pPr marL="0" indent="0">
               <a:buNone/>
             </a:pPr>
             <a:r>
@@ -10714,7 +10523,7 @@
           <a:bodyPr wrap="none" lIns="0" tIns="0" rIns="0" bIns="0" rtlCol="0" anchor="ctr"/>
           <a:lstStyle/>
           <a:p>
-            <a:pPr indent="0" marL="0">
+            <a:pPr marL="0" indent="0">
               <a:buNone/>
             </a:pPr>
             <a:r>
@@ -10728,9 +10537,6 @@
               </a:rPr>
               <a:t>0.713</a:t>
             </a:r>
-            <a:pPr indent="0" marL="0">
-              <a:buNone/>
-            </a:pPr>
             <a:r>
               <a:rPr lang="en-US" sz="2400" b="1" dirty="0">
                 <a:solidFill>
@@ -10742,9 +10548,6 @@
               </a:rPr>
               <a:t> → </a:t>
             </a:r>
-            <a:pPr indent="0" marL="0">
-              <a:buNone/>
-            </a:pPr>
             <a:r>
               <a:rPr lang="en-US" sz="4400" b="1" dirty="0">
                 <a:solidFill>
@@ -10781,7 +10584,7 @@
           <a:bodyPr wrap="square" lIns="508" tIns="508" rIns="508" bIns="508" rtlCol="0" anchor="t"/>
           <a:lstStyle/>
           <a:p>
-            <a:pPr indent="0" marL="0">
+            <a:pPr marL="0" indent="0">
               <a:buNone/>
             </a:pPr>
             <a:r>
@@ -10820,7 +10623,7 @@
           <a:bodyPr wrap="none" lIns="0" tIns="0" rIns="0" bIns="0" rtlCol="0" anchor="ctr"/>
           <a:lstStyle/>
           <a:p>
-            <a:pPr indent="0" marL="0">
+            <a:pPr marL="0" indent="0">
               <a:buNone/>
             </a:pPr>
             <a:r>
@@ -10834,9 +10637,6 @@
               </a:rPr>
               <a:t>0.721</a:t>
             </a:r>
-            <a:pPr indent="0" marL="0">
-              <a:buNone/>
-            </a:pPr>
             <a:r>
               <a:rPr lang="en-US" sz="2400" b="1" dirty="0">
                 <a:solidFill>
@@ -10848,9 +10648,6 @@
               </a:rPr>
               <a:t> → </a:t>
             </a:r>
-            <a:pPr indent="0" marL="0">
-              <a:buNone/>
-            </a:pPr>
             <a:r>
               <a:rPr lang="en-US" sz="4400" b="1" dirty="0">
                 <a:solidFill>
@@ -10887,7 +10684,7 @@
           <a:bodyPr wrap="square" lIns="508" tIns="508" rIns="508" bIns="508" rtlCol="0" anchor="t"/>
           <a:lstStyle/>
           <a:p>
-            <a:pPr indent="0" marL="0">
+            <a:pPr marL="0" indent="0">
               <a:buNone/>
             </a:pPr>
             <a:r>
@@ -10931,7 +10728,7 @@
             <a:prstDash val="solid"/>
           </a:ln>
           <a:effectLst>
-            <a:outerShdw sx="100000" sy="100000" kx="0" ky="0" algn="bl" rotWithShape="0" blurRad="101600" dist="25400" dir="5400000">
+            <a:outerShdw blurRad="101600" dist="25400" dir="5400000" algn="bl" rotWithShape="0">
               <a:srgbClr val="7FB8D6">
                 <a:alpha val="25000"/>
               </a:srgbClr>
@@ -10960,7 +10757,7 @@
           <a:bodyPr wrap="square" lIns="508" tIns="508" rIns="508" bIns="508" rtlCol="0" anchor="t"/>
           <a:lstStyle/>
           <a:p>
-            <a:pPr indent="0" marL="0">
+            <a:pPr marL="0" indent="0">
               <a:buNone/>
             </a:pPr>
             <a:r>
@@ -10999,7 +10796,7 @@
           <a:bodyPr wrap="square" lIns="0" tIns="0" rIns="0" bIns="0" rtlCol="0" anchor="ctr"/>
           <a:lstStyle/>
           <a:p>
-            <a:pPr indent="0" marL="0">
+            <a:pPr marL="0" indent="0">
               <a:buNone/>
             </a:pPr>
             <a:r>
@@ -11038,7 +10835,7 @@
           <a:bodyPr wrap="square" lIns="508" tIns="508" rIns="508" bIns="508" rtlCol="0" anchor="t"/>
           <a:lstStyle/>
           <a:p>
-            <a:pPr indent="0" marL="0">
+            <a:pPr marL="0" indent="0">
               <a:buNone/>
             </a:pPr>
             <a:r>
@@ -11052,9 +10849,6 @@
               </a:rPr>
               <a:t>LDA </a:t>
             </a:r>
-            <a:pPr indent="0" marL="0">
-              <a:buNone/>
-            </a:pPr>
             <a:r>
               <a:rPr lang="en-US" sz="2000" dirty="0">
                 <a:solidFill>
@@ -11091,7 +10885,7 @@
           <a:bodyPr wrap="square" lIns="0" tIns="0" rIns="0" bIns="0" rtlCol="0" anchor="ctr"/>
           <a:lstStyle/>
           <a:p>
-            <a:pPr indent="0" marL="0">
+            <a:pPr marL="0" indent="0">
               <a:buNone/>
             </a:pPr>
             <a:r>
@@ -11130,7 +10924,7 @@
           <a:bodyPr wrap="square" lIns="508" tIns="508" rIns="508" bIns="508" rtlCol="0" anchor="t"/>
           <a:lstStyle/>
           <a:p>
-            <a:pPr indent="0" marL="0">
+            <a:pPr marL="0" indent="0">
               <a:buNone/>
             </a:pPr>
             <a:r>
@@ -11144,9 +10938,6 @@
               </a:rPr>
               <a:t>Logística </a:t>
             </a:r>
-            <a:pPr indent="0" marL="0">
-              <a:buNone/>
-            </a:pPr>
             <a:r>
               <a:rPr lang="en-US" sz="2000" dirty="0">
                 <a:solidFill>
@@ -11188,7 +10979,7 @@
             <a:prstDash val="solid"/>
           </a:ln>
           <a:effectLst>
-            <a:outerShdw sx="100000" sy="100000" kx="0" ky="0" algn="bl" rotWithShape="0" blurRad="101600" dist="25400" dir="5400000">
+            <a:outerShdw blurRad="101600" dist="25400" dir="5400000" algn="bl" rotWithShape="0">
               <a:srgbClr val="7FB8D6">
                 <a:alpha val="25000"/>
               </a:srgbClr>
@@ -11217,7 +11008,7 @@
           <a:bodyPr wrap="square" lIns="508" tIns="508" rIns="508" bIns="508" rtlCol="0" anchor="t"/>
           <a:lstStyle/>
           <a:p>
-            <a:pPr indent="0" marL="0">
+            <a:pPr marL="0" indent="0">
               <a:buNone/>
             </a:pPr>
             <a:r>
@@ -11256,7 +11047,7 @@
           <a:bodyPr wrap="none" lIns="0" tIns="0" rIns="0" bIns="0" rtlCol="0" anchor="ctr"/>
           <a:lstStyle/>
           <a:p>
-            <a:pPr indent="0" marL="0">
+            <a:pPr marL="0" indent="0">
               <a:buNone/>
             </a:pPr>
             <a:r>
@@ -11270,9 +11061,6 @@
               </a:rPr>
               <a:t>56 %</a:t>
             </a:r>
-            <a:pPr indent="0" marL="0">
-              <a:buNone/>
-            </a:pPr>
             <a:r>
               <a:rPr lang="en-US" sz="2400" b="1" dirty="0">
                 <a:solidFill>
@@ -11284,9 +11072,6 @@
               </a:rPr>
               <a:t> → </a:t>
             </a:r>
-            <a:pPr indent="0" marL="0">
-              <a:buNone/>
-            </a:pPr>
             <a:r>
               <a:rPr lang="en-US" sz="4400" b="1" dirty="0">
                 <a:solidFill>
@@ -11323,7 +11108,7 @@
           <a:bodyPr wrap="square" lIns="508" tIns="508" rIns="508" bIns="508" rtlCol="0" anchor="ctr"/>
           <a:lstStyle/>
           <a:p>
-            <a:pPr indent="0" marL="0">
+            <a:pPr marL="0" indent="0">
               <a:buNone/>
             </a:pPr>
             <a:r>
@@ -11361,7 +11146,7 @@
           </a:prstGeom>
           <a:extLst>
             <a:ext uri="{C572A759-6A51-4108-AA02-DFA0A04FC94B}">
-              <ma14:wrappingTextBoxFlag xmlns:ma14="http://schemas.microsoft.com/office/mac/drawingml/2011/main" val="0"/>
+              <ma14:wrappingTextBoxFlag xmlns:ma14="http://schemas.microsoft.com/office/mac/drawingml/2011/main" xmlns="" val="0"/>
             </a:ext>
           </a:extLst>
         </p:spPr>
@@ -11382,7 +11167,7 @@
           <a:p>
             <a:pPr algn="r"/>
             <a:fld id="{F7021451-1387-4CA6-816F-3879F97B5CBC}" type="slidenum">
-              <a:rPr b="0" lang="en-US"/>
+              <a:rPr lang="en-US" b="0"/>
               <a:t>8</a:t>
             </a:fld>
             <a:endParaRPr lang="en-US"/>
@@ -11417,9 +11202,11 @@
       <p:sp>
         <p:nvSpPr>
           <p:cNvPr id="2" name="Text 0"/>
-          <p:cNvSpPr/>
+          <p:cNvSpPr>
+            <a:spLocks noGrp="1"/>
+          </p:cNvSpPr>
           <p:nvPr>
-            <p:ph idx="100" type="title" hasCustomPrompt="1"/>
+            <p:ph type="title" idx="100" hasCustomPrompt="1"/>
           </p:nvPr>
         </p:nvSpPr>
         <p:spPr>
@@ -11437,7 +11224,7 @@
           <a:bodyPr wrap="square" lIns="0" tIns="0" rIns="0" bIns="0" rtlCol="0" anchor="ctr"/>
           <a:lstStyle/>
           <a:p>
-            <a:pPr algn="l" indent="0" marL="0">
+            <a:pPr marL="0" indent="0" algn="l">
               <a:buNone/>
             </a:pPr>
             <a:r>
@@ -11528,7 +11315,7 @@
           <a:bodyPr wrap="square" lIns="0" tIns="0" rIns="0" bIns="0" rtlCol="0" anchor="ctr"/>
           <a:lstStyle/>
           <a:p>
-            <a:pPr indent="0" marL="0">
+            <a:pPr marL="0" indent="0">
               <a:buNone/>
             </a:pPr>
             <a:r>
@@ -11572,7 +11359,7 @@
             <a:prstDash val="solid"/>
           </a:ln>
           <a:effectLst>
-            <a:outerShdw sx="100000" sy="100000" kx="0" ky="0" algn="bl" rotWithShape="0" blurRad="101600" dist="25400" dir="5400000">
+            <a:outerShdw blurRad="101600" dist="25400" dir="5400000" algn="bl" rotWithShape="0">
               <a:srgbClr val="7FB8D6">
                 <a:alpha val="25000"/>
               </a:srgbClr>
@@ -11601,7 +11388,7 @@
           <a:bodyPr wrap="square" lIns="508" tIns="508" rIns="508" bIns="508" rtlCol="0" anchor="t"/>
           <a:lstStyle/>
           <a:p>
-            <a:pPr indent="0" marL="0">
+            <a:pPr marL="0" indent="0">
               <a:buNone/>
             </a:pPr>
             <a:r>
@@ -11621,14 +11408,14 @@
       </p:sp>
       <p:pic>
         <p:nvPicPr>
-          <p:cNvPr id="8" name="pres_dauc_temporada.png" descr="Mejora del AUC por temporada con intervalo de 95 por ciento">    </p:cNvPr>
+          <p:cNvPr id="8" name="pres_dauc_temporada.png" descr="Mejora del AUC por temporada con intervalo de 95 por ciento"/>
           <p:cNvPicPr>
             <a:picLocks noChangeAspect="1"/>
           </p:cNvPicPr>
           <p:nvPr/>
         </p:nvPicPr>
         <p:blipFill>
-          <a:blip r:embed="rId1"/>
+          <a:blip r:embed="rId3"/>
           <a:stretch>
             <a:fillRect/>
           </a:stretch>
@@ -11664,7 +11451,7 @@
           <a:bodyPr wrap="square" lIns="508" tIns="508" rIns="508" bIns="508" rtlCol="0" anchor="t"/>
           <a:lstStyle/>
           <a:p>
-            <a:pPr indent="0" marL="0">
+            <a:pPr marL="0" indent="0">
               <a:buNone/>
             </a:pPr>
             <a:r>
@@ -11678,9 +11465,6 @@
               </a:rPr>
               <a:t>Marzo–mayo: +0.151. </a:t>
             </a:r>
-            <a:pPr indent="0" marL="0">
-              <a:buNone/>
-            </a:pPr>
             <a:r>
               <a:rPr lang="en-US" sz="2000" dirty="0">
                 <a:solidFill>
@@ -11722,7 +11506,7 @@
             <a:prstDash val="solid"/>
           </a:ln>
           <a:effectLst>
-            <a:outerShdw sx="100000" sy="100000" kx="0" ky="0" algn="bl" rotWithShape="0" blurRad="101600" dist="25400" dir="5400000">
+            <a:outerShdw blurRad="101600" dist="25400" dir="5400000" algn="bl" rotWithShape="0">
               <a:srgbClr val="7FB8D6">
                 <a:alpha val="25000"/>
               </a:srgbClr>
@@ -11751,7 +11535,7 @@
           <a:bodyPr wrap="square" lIns="508" tIns="508" rIns="508" bIns="508" rtlCol="0" anchor="t"/>
           <a:lstStyle/>
           <a:p>
-            <a:pPr indent="0" marL="0">
+            <a:pPr marL="0" indent="0">
               <a:buNone/>
             </a:pPr>
             <a:r>
@@ -11771,14 +11555,14 @@
       </p:sp>
       <p:pic>
         <p:nvPicPr>
-          <p:cNvPr id="12" name="pres_or_logistica.png" descr="Odds ratio por una desviación estándar de las variables meteorológicas de signo estable">    </p:cNvPr>
+          <p:cNvPr id="12" name="pres_or_logistica.png" descr="Odds ratio por una desviación estándar de las variables meteorológicas de signo estable"/>
           <p:cNvPicPr>
             <a:picLocks noChangeAspect="1"/>
           </p:cNvPicPr>
           <p:nvPr/>
         </p:nvPicPr>
         <p:blipFill>
-          <a:blip r:embed="rId2"/>
+          <a:blip r:embed="rId4"/>
           <a:stretch>
             <a:fillRect/>
           </a:stretch>
@@ -11814,7 +11598,7 @@
           <a:bodyPr wrap="square" lIns="508" tIns="508" rIns="508" bIns="508" rtlCol="0" anchor="t"/>
           <a:lstStyle/>
           <a:p>
-            <a:pPr indent="0" marL="0">
+            <a:pPr marL="0" indent="0">
               <a:buNone/>
             </a:pPr>
             <a:r>
@@ -11828,9 +11612,6 @@
               </a:rPr>
               <a:t>Se asocia, no causa. </a:t>
             </a:r>
-            <a:pPr indent="0" marL="0">
-              <a:buNone/>
-            </a:pPr>
             <a:r>
               <a:rPr lang="en-US" sz="2000" dirty="0">
                 <a:solidFill>
@@ -11866,7 +11647,7 @@
           </a:prstGeom>
           <a:extLst>
             <a:ext uri="{C572A759-6A51-4108-AA02-DFA0A04FC94B}">
-              <ma14:wrappingTextBoxFlag xmlns:ma14="http://schemas.microsoft.com/office/mac/drawingml/2011/main" val="0"/>
+              <ma14:wrappingTextBoxFlag xmlns:ma14="http://schemas.microsoft.com/office/mac/drawingml/2011/main" xmlns="" val="0"/>
             </a:ext>
           </a:extLst>
         </p:spPr>
@@ -11887,7 +11668,7 @@
           <a:p>
             <a:pPr algn="r"/>
             <a:fld id="{F7021451-1387-4CA6-816F-3879F97B5CBC}" type="slidenum">
-              <a:rPr b="0" lang="en-US"/>
+              <a:rPr lang="en-US" b="0"/>
               <a:t>9</a:t>
             </a:fld>
             <a:endParaRPr lang="en-US"/>
@@ -12195,4 +11976,319 @@
     </a:ext>
   </a:extLst>
 </a:theme>
+</file>
+
+<file path=ppt/theme/theme2.xml><?xml version="1.0" encoding="utf-8"?>
+<a:theme xmlns:a="http://schemas.openxmlformats.org/drawingml/2006/main" name="Office Theme">
+  <a:themeElements>
+    <a:clrScheme name="Office">
+      <a:dk1>
+        <a:sysClr val="windowText" lastClr="000000"/>
+      </a:dk1>
+      <a:lt1>
+        <a:sysClr val="window" lastClr="FFFFFF"/>
+      </a:lt1>
+      <a:dk2>
+        <a:srgbClr val="0E2841"/>
+      </a:dk2>
+      <a:lt2>
+        <a:srgbClr val="E8E8E8"/>
+      </a:lt2>
+      <a:accent1>
+        <a:srgbClr val="156082"/>
+      </a:accent1>
+      <a:accent2>
+        <a:srgbClr val="E97132"/>
+      </a:accent2>
+      <a:accent3>
+        <a:srgbClr val="196B24"/>
+      </a:accent3>
+      <a:accent4>
+        <a:srgbClr val="0F9ED5"/>
+      </a:accent4>
+      <a:accent5>
+        <a:srgbClr val="A02B93"/>
+      </a:accent5>
+      <a:accent6>
+        <a:srgbClr val="4EA72E"/>
+      </a:accent6>
+      <a:hlink>
+        <a:srgbClr val="467886"/>
+      </a:hlink>
+      <a:folHlink>
+        <a:srgbClr val="96607D"/>
+      </a:folHlink>
+    </a:clrScheme>
+    <a:fontScheme name="Office">
+      <a:majorFont>
+        <a:latin typeface="Aptos Display" panose="02110004020202020204"/>
+        <a:ea typeface=""/>
+        <a:cs typeface=""/>
+        <a:font script="Jpan" typeface="游ゴシック Light"/>
+        <a:font script="Hang" typeface="맑은 고딕"/>
+        <a:font script="Hans" typeface="等线 Light"/>
+        <a:font script="Hant" typeface="新細明體"/>
+        <a:font script="Arab" typeface="Times New Roman"/>
+        <a:font script="Hebr" typeface="Times New Roman"/>
+        <a:font script="Thai" typeface="Angsana New"/>
+        <a:font script="Ethi" typeface="Nyala"/>
+        <a:font script="Beng" typeface="Vrinda"/>
+        <a:font script="Gujr" typeface="Shruti"/>
+        <a:font script="Khmr" typeface="MoolBoran"/>
+        <a:font script="Knda" typeface="Tunga"/>
+        <a:font script="Guru" typeface="Raavi"/>
+        <a:font script="Cans" typeface="Euphemia"/>
+        <a:font script="Cher" typeface="Plantagenet Cherokee"/>
+        <a:font script="Yiii" typeface="Microsoft Yi Baiti"/>
+        <a:font script="Tibt" typeface="Microsoft Himalaya"/>
+        <a:font script="Thaa" typeface="MV Boli"/>
+        <a:font script="Deva" typeface="Mangal"/>
+        <a:font script="Telu" typeface="Gautami"/>
+        <a:font script="Taml" typeface="Latha"/>
+        <a:font script="Syrc" typeface="Estrangelo Edessa"/>
+        <a:font script="Orya" typeface="Kalinga"/>
+        <a:font script="Mlym" typeface="Kartika"/>
+        <a:font script="Laoo" typeface="DokChampa"/>
+        <a:font script="Sinh" typeface="Iskoola Pota"/>
+        <a:font script="Mong" typeface="Mongolian Baiti"/>
+        <a:font script="Viet" typeface="Times New Roman"/>
+        <a:font script="Uigh" typeface="Microsoft Uighur"/>
+        <a:font script="Geor" typeface="Sylfaen"/>
+        <a:font script="Armn" typeface="Arial"/>
+        <a:font script="Bugi" typeface="Leelawadee UI"/>
+        <a:font script="Bopo" typeface="Microsoft JhengHei"/>
+        <a:font script="Java" typeface="Javanese Text"/>
+        <a:font script="Lisu" typeface="Segoe UI"/>
+        <a:font script="Mymr" typeface="Myanmar Text"/>
+        <a:font script="Nkoo" typeface="Ebrima"/>
+        <a:font script="Olck" typeface="Nirmala UI"/>
+        <a:font script="Osma" typeface="Ebrima"/>
+        <a:font script="Phag" typeface="Phagspa"/>
+        <a:font script="Syrn" typeface="Estrangelo Edessa"/>
+        <a:font script="Syrj" typeface="Estrangelo Edessa"/>
+        <a:font script="Syre" typeface="Estrangelo Edessa"/>
+        <a:font script="Sora" typeface="Nirmala UI"/>
+        <a:font script="Tale" typeface="Microsoft Tai Le"/>
+        <a:font script="Talu" typeface="Microsoft New Tai Lue"/>
+        <a:font script="Tfng" typeface="Ebrima"/>
+      </a:majorFont>
+      <a:minorFont>
+        <a:latin typeface="Aptos" panose="02110004020202020204"/>
+        <a:ea typeface=""/>
+        <a:cs typeface=""/>
+        <a:font script="Jpan" typeface="游ゴシック"/>
+        <a:font script="Hang" typeface="맑은 고딕"/>
+        <a:font script="Hans" typeface="等线"/>
+        <a:font script="Hant" typeface="新細明體"/>
+        <a:font script="Arab" typeface="Arial"/>
+        <a:font script="Hebr" typeface="Arial"/>
+        <a:font script="Thai" typeface="Cordia New"/>
+        <a:font script="Ethi" typeface="Nyala"/>
+        <a:font script="Beng" typeface="Vrinda"/>
+        <a:font script="Gujr" typeface="Shruti"/>
+        <a:font script="Khmr" typeface="DaunPenh"/>
+        <a:font script="Knda" typeface="Tunga"/>
+        <a:font script="Guru" typeface="Raavi"/>
+        <a:font script="Cans" typeface="Euphemia"/>
+        <a:font script="Cher" typeface="Plantagenet Cherokee"/>
+        <a:font script="Yiii" typeface="Microsoft Yi Baiti"/>
+        <a:font script="Tibt" typeface="Microsoft Himalaya"/>
+        <a:font script="Thaa" typeface="MV Boli"/>
+        <a:font script="Deva" typeface="Mangal"/>
+        <a:font script="Telu" typeface="Gautami"/>
+        <a:font script="Taml" typeface="Latha"/>
+        <a:font script="Syrc" typeface="Estrangelo Edessa"/>
+        <a:font script="Orya" typeface="Kalinga"/>
+        <a:font script="Mlym" typeface="Kartika"/>
+        <a:font script="Laoo" typeface="DokChampa"/>
+        <a:font script="Sinh" typeface="Iskoola Pota"/>
+        <a:font script="Mong" typeface="Mongolian Baiti"/>
+        <a:font script="Viet" typeface="Arial"/>
+        <a:font script="Uigh" typeface="Microsoft Uighur"/>
+        <a:font script="Geor" typeface="Sylfaen"/>
+        <a:font script="Armn" typeface="Arial"/>
+        <a:font script="Bugi" typeface="Leelawadee UI"/>
+        <a:font script="Bopo" typeface="Microsoft JhengHei"/>
+        <a:font script="Java" typeface="Javanese Text"/>
+        <a:font script="Lisu" typeface="Segoe UI"/>
+        <a:font script="Mymr" typeface="Myanmar Text"/>
+        <a:font script="Nkoo" typeface="Ebrima"/>
+        <a:font script="Olck" typeface="Nirmala UI"/>
+        <a:font script="Osma" typeface="Ebrima"/>
+        <a:font script="Phag" typeface="Phagspa"/>
+        <a:font script="Syrn" typeface="Estrangelo Edessa"/>
+        <a:font script="Syrj" typeface="Estrangelo Edessa"/>
+        <a:font script="Syre" typeface="Estrangelo Edessa"/>
+        <a:font script="Sora" typeface="Nirmala UI"/>
+        <a:font script="Tale" typeface="Microsoft Tai Le"/>
+        <a:font script="Talu" typeface="Microsoft New Tai Lue"/>
+        <a:font script="Tfng" typeface="Ebrima"/>
+      </a:minorFont>
+    </a:fontScheme>
+    <a:fmtScheme name="Office">
+      <a:fillStyleLst>
+        <a:solidFill>
+          <a:schemeClr val="phClr"/>
+        </a:solidFill>
+        <a:gradFill rotWithShape="1">
+          <a:gsLst>
+            <a:gs pos="0">
+              <a:schemeClr val="phClr">
+                <a:lumMod val="110000"/>
+                <a:satMod val="105000"/>
+                <a:tint val="67000"/>
+              </a:schemeClr>
+            </a:gs>
+            <a:gs pos="50000">
+              <a:schemeClr val="phClr">
+                <a:lumMod val="105000"/>
+                <a:satMod val="103000"/>
+                <a:tint val="73000"/>
+              </a:schemeClr>
+            </a:gs>
+            <a:gs pos="100000">
+              <a:schemeClr val="phClr">
+                <a:lumMod val="105000"/>
+                <a:satMod val="109000"/>
+                <a:tint val="81000"/>
+              </a:schemeClr>
+            </a:gs>
+          </a:gsLst>
+          <a:lin ang="5400000" scaled="0"/>
+        </a:gradFill>
+        <a:gradFill rotWithShape="1">
+          <a:gsLst>
+            <a:gs pos="0">
+              <a:schemeClr val="phClr">
+                <a:satMod val="103000"/>
+                <a:lumMod val="102000"/>
+                <a:tint val="94000"/>
+              </a:schemeClr>
+            </a:gs>
+            <a:gs pos="50000">
+              <a:schemeClr val="phClr">
+                <a:satMod val="110000"/>
+                <a:lumMod val="100000"/>
+                <a:shade val="100000"/>
+              </a:schemeClr>
+            </a:gs>
+            <a:gs pos="100000">
+              <a:schemeClr val="phClr">
+                <a:lumMod val="99000"/>
+                <a:satMod val="120000"/>
+                <a:shade val="78000"/>
+              </a:schemeClr>
+            </a:gs>
+          </a:gsLst>
+          <a:lin ang="5400000" scaled="0"/>
+        </a:gradFill>
+      </a:fillStyleLst>
+      <a:lnStyleLst>
+        <a:ln w="12700" cap="flat" cmpd="sng" algn="ctr">
+          <a:solidFill>
+            <a:schemeClr val="phClr"/>
+          </a:solidFill>
+          <a:prstDash val="solid"/>
+          <a:miter lim="800000"/>
+        </a:ln>
+        <a:ln w="19050" cap="flat" cmpd="sng" algn="ctr">
+          <a:solidFill>
+            <a:schemeClr val="phClr"/>
+          </a:solidFill>
+          <a:prstDash val="solid"/>
+          <a:miter lim="800000"/>
+        </a:ln>
+        <a:ln w="25400" cap="flat" cmpd="sng" algn="ctr">
+          <a:solidFill>
+            <a:schemeClr val="phClr"/>
+          </a:solidFill>
+          <a:prstDash val="solid"/>
+          <a:miter lim="800000"/>
+        </a:ln>
+      </a:lnStyleLst>
+      <a:effectStyleLst>
+        <a:effectStyle>
+          <a:effectLst/>
+        </a:effectStyle>
+        <a:effectStyle>
+          <a:effectLst/>
+        </a:effectStyle>
+        <a:effectStyle>
+          <a:effectLst>
+            <a:outerShdw blurRad="57150" dist="19050" dir="5400000" algn="ctr" rotWithShape="0">
+              <a:srgbClr val="000000">
+                <a:alpha val="63000"/>
+              </a:srgbClr>
+            </a:outerShdw>
+          </a:effectLst>
+        </a:effectStyle>
+      </a:effectStyleLst>
+      <a:bgFillStyleLst>
+        <a:solidFill>
+          <a:schemeClr val="phClr"/>
+        </a:solidFill>
+        <a:solidFill>
+          <a:schemeClr val="phClr">
+            <a:tint val="95000"/>
+            <a:satMod val="170000"/>
+          </a:schemeClr>
+        </a:solidFill>
+        <a:gradFill rotWithShape="1">
+          <a:gsLst>
+            <a:gs pos="0">
+              <a:schemeClr val="phClr">
+                <a:tint val="93000"/>
+                <a:satMod val="150000"/>
+                <a:shade val="98000"/>
+                <a:lumMod val="102000"/>
+              </a:schemeClr>
+            </a:gs>
+            <a:gs pos="50000">
+              <a:schemeClr val="phClr">
+                <a:tint val="98000"/>
+                <a:satMod val="130000"/>
+                <a:shade val="90000"/>
+                <a:lumMod val="103000"/>
+              </a:schemeClr>
+            </a:gs>
+            <a:gs pos="100000">
+              <a:schemeClr val="phClr">
+                <a:shade val="63000"/>
+                <a:satMod val="120000"/>
+              </a:schemeClr>
+            </a:gs>
+          </a:gsLst>
+          <a:lin ang="5400000" scaled="0"/>
+        </a:gradFill>
+      </a:bgFillStyleLst>
+    </a:fmtScheme>
+  </a:themeElements>
+  <a:objectDefaults>
+    <a:lnDef>
+      <a:spPr/>
+      <a:bodyPr/>
+      <a:lstStyle/>
+      <a:style>
+        <a:lnRef idx="2">
+          <a:schemeClr val="accent1"/>
+        </a:lnRef>
+        <a:fillRef idx="0">
+          <a:schemeClr val="accent1"/>
+        </a:fillRef>
+        <a:effectRef idx="1">
+          <a:schemeClr val="accent1"/>
+        </a:effectRef>
+        <a:fontRef idx="minor">
+          <a:schemeClr val="tx1"/>
+        </a:fontRef>
+      </a:style>
+    </a:lnDef>
+  </a:objectDefaults>
+  <a:extraClrSchemeLst/>
+  <a:extLst>
+    <a:ext uri="{05A4C25C-085E-4340-85A3-A5531E510DB2}">
+      <thm15:themeFamily xmlns:thm15="http://schemas.microsoft.com/office/thememl/2012/main" name="Office Theme" id="{2E142A2C-CD16-42D6-873A-C26D2A0506FA}" vid="{1BDDFF52-6CD6-40A5-AB3C-68EB2F1E4D0A}"/>
+    </a:ext>
+  </a:extLst>
+</a:theme>
 </file>
</xml_diff>